<commit_message>
USA Population Geography L1-L18 and PW1-PW4 rewritten along the syllabus in the validated style
Co-Authored-By: Claude Opus 5.5 <noreply@anthropic.com>
Claude-Session: https://claude.ai/code/session_0115LFSb2ktGLWPeVksFkSer
</commit_message>
<xml_diff>
--- a/lecons/USA/Population Geography/03_USA_POP_PW01_Techniques_of_Mapping_Population_Distribution_and_Density.pptx
+++ b/lecons/USA/Population Geography/03_USA_POP_PW01_Techniques_of_Mapping_Population_Distribution_and_Density.pptx
@@ -67,12 +67,9 @@
     <p:sldId id="315" r:id="rId61"/>
     <p:sldId id="316" r:id="rId62"/>
     <p:sldId id="317" r:id="rId63"/>
-    <p:sldId id="318" r:id="rId64"/>
-    <p:sldId id="319" r:id="rId65"/>
-    <p:sldId id="320" r:id="rId66"/>
   </p:sldIdLst>
   <p:notesMasterIdLst>
-    <p:notesMasterId r:id="rId67"/>
+    <p:notesMasterId r:id="rId64"/>
   </p:notesMasterIdLst>
   <p:sldSz cx="12192000" cy="6858000"/>
   <p:notesSz cx="6858000" cy="12192000"/>
@@ -3382,7 +3379,7 @@
           <a:p>
             <a:r>
               <a:rPr lang="en-US" dirty="0"/>
-              <a:t>Let us copy Techniques of Mapping Population Distribution and Density. The main mapping techniques are the following. Copy the point on Choropleth map on the left, then draw the diagram on the right: a choropleth map. Give it a title and label it clearly.</a:t>
+              <a:t>Let us copy Techniques of Mapping Population Distribution and Density. Population is mapped with the following techniques. Copy the point on Choropleth map on the left, then draw the diagram on the right: a choropleth map. Give it a title and label it clearly.</a:t>
             </a:r>
             <a:endParaRPr lang="en-US" dirty="0"/>
           </a:p>
@@ -3822,7 +3819,7 @@
           <a:p>
             <a:r>
               <a:rPr lang="en-US" dirty="0"/>
-              <a:t>Let us copy Other Methods Showing Unevenness. The other methods showing the unevenness of distribution are the following. Copy the point on The Lorenz curve on the left, then draw the diagram on the right: a Lorenz curve for Cameroon. Give it a title and label it clearly.</a:t>
+              <a:t>Let us copy Showing Uneven Distribution. The unevenness of distribution is shown with the following methods. Copy the point on Constructing the Lorenz curve on the left, then draw the diagram on the right: a Lorenz curve. Give it a title and label it clearly.</a:t>
             </a:r>
             <a:endParaRPr lang="en-US" dirty="0"/>
           </a:p>
@@ -3910,7 +3907,7 @@
           <a:p>
             <a:r>
               <a:rPr lang="en-US" dirty="0"/>
-              <a:t>We continue with Other Methods Showing Unevenness. On this slide we have Reading the Lorenz curve. Write each point on a new line, with the key term first, and explain it in your own words when we revise.</a:t>
+              <a:t>We continue with Showing Uneven Distribution. Copy the point on Reading the Lorenz curve: write the key term first, then its explanation.</a:t>
             </a:r>
             <a:endParaRPr lang="en-US" dirty="0"/>
           </a:p>
@@ -3998,7 +3995,7 @@
           <a:p>
             <a:r>
               <a:rPr lang="en-US" dirty="0"/>
-              <a:t>Copy the point on The density lapse rate on the left, then draw the diagram on the right: a density lapse graph. Give it a title and label it clearly.</a:t>
+              <a:t>Copy the point on The density lapse rate on the left, then draw the diagram on the right: a density lapse rate. Give it a title and label it clearly.</a:t>
             </a:r>
             <a:endParaRPr lang="en-US" dirty="0"/>
           </a:p>
@@ -4086,7 +4083,7 @@
           <a:p>
             <a:r>
               <a:rPr lang="en-US" dirty="0"/>
-              <a:t>We continue with Other Methods Showing Unevenness. On this slide we have Example. Write each point on a new line, with the key term first, and explain it in your own words when we revise.</a:t>
+              <a:t>Let us copy Assessment of the Techniques. The techniques have the following advantages and disadvantages. Copy the point on Choropleth map: write the key term first, then its explanation.</a:t>
             </a:r>
             <a:endParaRPr lang="en-US" dirty="0"/>
           </a:p>
@@ -4174,7 +4171,7 @@
           <a:p>
             <a:r>
               <a:rPr lang="en-US" dirty="0"/>
-              <a:t>Let us copy Assessment of the Techniques. The advantages and disadvantages of the techniques are the following. On this slide we have Choropleth map. Write each point on a new line, with the key term first, and explain it in your own words when we revise. When you finish, we go to the next slide.</a:t>
+              <a:t>We continue with Assessment of the Techniques. Copy the point on Isopleth map: write the key term first, then its explanation.</a:t>
             </a:r>
             <a:endParaRPr lang="en-US" dirty="0"/>
           </a:p>
@@ -4262,7 +4259,7 @@
           <a:p>
             <a:r>
               <a:rPr lang="en-US" dirty="0"/>
-              <a:t>We continue with Assessment of the Techniques. On this slide we have Isopleth map. Write each point on a new line, with the key term first, and explain it in your own words when we revise. When you finish, we go to the next slide.</a:t>
+              <a:t>We continue with Assessment of the Techniques. Copy the point on Dot map and proportional symbols: write the key term first, then its explanation.</a:t>
             </a:r>
             <a:endParaRPr lang="en-US" dirty="0"/>
           </a:p>
@@ -4350,7 +4347,7 @@
           <a:p>
             <a:r>
               <a:rPr lang="en-US" dirty="0"/>
-              <a:t>We continue with Assessment of the Techniques. On this slide we have Dot map. Write each point on a new line, with the key term first, and explain it in your own words when we revise. When you finish, we go to the next slide.</a:t>
+              <a:t>We continue with Assessment of the Techniques. Copy the point on Lorenz curve and lapse rate: write the key term first, then its explanation.</a:t>
             </a:r>
             <a:endParaRPr lang="en-US" dirty="0"/>
           </a:p>
@@ -4526,7 +4523,7 @@
           <a:p>
             <a:r>
               <a:rPr lang="en-US" dirty="0"/>
-              <a:t>We continue with Assessment of the Techniques. On this slide we have Proportional symbols. Write each point on a new line, with the key term first, and explain it in your own words when we revise. When you finish, we go to the next slide.</a:t>
+              <a:t>Now let us check what you have understood. Question 1: Give one advantage and one disadvantage of the dot map. Answer in your exercise book.</a:t>
             </a:r>
             <a:endParaRPr lang="en-US" dirty="0"/>
           </a:p>
@@ -4614,7 +4611,7 @@
           <a:p>
             <a:r>
               <a:rPr lang="en-US" dirty="0"/>
-              <a:t>We continue with Assessment of the Techniques. On this slide we have Lorenz curve and lapse rate. Write each point on a new line, with the key term first, and explain it in your own words when we revise. When you finish, we go to the next slide.</a:t>
+              <a:t>The expected answer is: advantage: it shows the real pattern of population; disadvantage: dots merge in dense areas. If you got it right, well done.</a:t>
             </a:r>
             <a:endParaRPr lang="en-US" dirty="0"/>
           </a:p>
@@ -4702,7 +4699,7 @@
           <a:p>
             <a:r>
               <a:rPr lang="en-US" dirty="0"/>
-              <a:t>We continue with Assessment of the Techniques. Copy this carefully.</a:t>
+              <a:t>Now let us check what you have understood. Question 2: What does a Lorenz curve far from the diagonal show? Answer in your exercise book.</a:t>
             </a:r>
             <a:endParaRPr lang="en-US" dirty="0"/>
           </a:p>
@@ -4790,7 +4787,7 @@
           <a:p>
             <a:r>
               <a:rPr lang="en-US" dirty="0"/>
-              <a:t>Now let us check what you have understood. Question 1: Give one advantage and one disadvantage of the dot map. Answer in your exercise book.</a:t>
+              <a:t>The expected answer is: a very uneven distribution of the population. If you got it right, well done.</a:t>
             </a:r>
             <a:endParaRPr lang="en-US" dirty="0"/>
           </a:p>
@@ -4878,7 +4875,7 @@
           <a:p>
             <a:r>
               <a:rPr lang="en-US" dirty="0"/>
-              <a:t>The expected answer is: advantage: it shows the real pattern of population; disadvantage: dots merge in dense areas. If you got it right, well done.</a:t>
+              <a:t>Take your time to copy this part; we will continue together.</a:t>
             </a:r>
             <a:endParaRPr lang="en-US" dirty="0"/>
           </a:p>
@@ -4966,7 +4963,7 @@
           <a:p>
             <a:r>
               <a:rPr lang="en-US" dirty="0"/>
-              <a:t>Now let us check what you have understood. Question 2: What does a Lorenz curve far from the diagonal show? Answer in your exercise book.</a:t>
+              <a:t>For those who need more practice, fill in the blanks in your exercise book. The answers are: number 1, choropleth; number 2, isopleths; number 3, Lorenz.</a:t>
             </a:r>
             <a:endParaRPr lang="en-US" dirty="0"/>
           </a:p>
@@ -5054,7 +5051,7 @@
           <a:p>
             <a:r>
               <a:rPr lang="en-US" dirty="0"/>
-              <a:t>The expected answer is: a very uneven distribution of the population. If you got it right, well done.</a:t>
+              <a:t>For your homework: Name two regions of the world that are densely populated. We shall correct it at the beginning of our next lesson.</a:t>
             </a:r>
             <a:endParaRPr lang="en-US" dirty="0"/>
           </a:p>
@@ -5142,7 +5139,7 @@
           <a:p>
             <a:r>
               <a:rPr lang="en-US" dirty="0"/>
-              <a:t>Take your time to copy this part; we will continue together.</a:t>
+              <a:t>Our next lesson will be on Lesson 3: Spatial Population Distribution and its Factors. Thank you for your attention, and see you next time.</a:t>
             </a:r>
             <a:endParaRPr lang="en-US" dirty="0"/>
           </a:p>
@@ -5230,7 +5227,7 @@
           <a:p>
             <a:r>
               <a:rPr lang="en-US" dirty="0"/>
-              <a:t>For those who need more practice, fill in the blanks in your exercise book. The answers are: number 1, choropleth; number 2, isopleths; number 3, Lorenz.</a:t>
+              <a:t>Let us play the bilingual game. I say a word in English, and you give me the French word. Then we do the reverse.</a:t>
             </a:r>
             <a:endParaRPr lang="en-US" dirty="0"/>
           </a:p>
@@ -5318,7 +5315,7 @@
           <a:p>
             <a:r>
               <a:rPr lang="en-US" dirty="0"/>
-              <a:t>For your homework: Name two regions of the world that are densely populated. We shall correct it at the beginning of our next lesson.</a:t>
+              <a:t>I record this information in the official logbook of the class after the lesson.</a:t>
             </a:r>
             <a:endParaRPr lang="en-US" dirty="0"/>
           </a:p>
@@ -5494,7 +5491,7 @@
           <a:p>
             <a:r>
               <a:rPr lang="en-US" dirty="0"/>
-              <a:t>Our next lesson will be on Lesson 3: Spatial Population Distribution and its Factors. Thank you for your attention, and see you next time.</a:t>
+              <a:t>I complete the second page of the logbook: the matter taught, the evaluation, the homework and the attendance.</a:t>
             </a:r>
             <a:endParaRPr lang="en-US" dirty="0"/>
           </a:p>
@@ -5582,7 +5579,7 @@
           <a:p>
             <a:r>
               <a:rPr lang="en-US" dirty="0"/>
-              <a:t>Let us play the bilingual game. I say a word in English, and you give me the French word. Then we do the reverse.</a:t>
+              <a:t>This slide is for me, the teacher: it gives the timing of the lesson and what to do if the projector is not available.</a:t>
             </a:r>
             <a:endParaRPr lang="en-US" dirty="0"/>
           </a:p>
@@ -5670,7 +5667,7 @@
           <a:p>
             <a:r>
               <a:rPr lang="en-US" dirty="0"/>
-              <a:t>I record this information in the official logbook of the class after the lesson.</a:t>
+              <a:t>These are the references and picture credits used to prepare this lesson.</a:t>
             </a:r>
             <a:endParaRPr lang="en-US" dirty="0"/>
           </a:p>
@@ -5694,270 +5691,6 @@
             <a:fld id="{F7021451-1387-4CA6-816F-3879F97B5CBC}" type="slidenum">
               <a:rPr lang="en-US"/>
               <a:t>62</a:t>
-            </a:fld>
-            <a:endParaRPr lang="en-US"/>
-          </a:p>
-        </p:txBody>
-      </p:sp>
-    </p:spTree>
-    <p:extLst>
-      <p:ext uri="{BB962C8B-B14F-4D97-AF65-F5344CB8AC3E}">
-        <p14:creationId xmlns:p14="http://schemas.microsoft.com/office/powerpoint/2010/main" val="1024086991"/>
-      </p:ext>
-    </p:extLst>
-  </p:cSld>
-  <p:clrMapOvr>
-    <a:masterClrMapping/>
-  </p:clrMapOvr>
-</p:notes>
-</file>
-
-<file path=ppt/notesSlides/notesSlide63.xml><?xml version="1.0" encoding="utf-8"?>
-<p:notes xmlns:a="http://schemas.openxmlformats.org/drawingml/2006/main" xmlns:r="http://schemas.openxmlformats.org/officeDocument/2006/relationships" xmlns:p="http://schemas.openxmlformats.org/presentationml/2006/main">
-  <p:cSld>
-    <p:spTree>
-      <p:nvGrpSpPr>
-        <p:cNvPr id="1" name=""/>
-        <p:cNvGrpSpPr/>
-        <p:nvPr/>
-      </p:nvGrpSpPr>
-      <p:grpSpPr>
-        <a:xfrm>
-          <a:off x="0" y="0"/>
-          <a:ext cx="0" cy="0"/>
-          <a:chOff x="0" y="0"/>
-          <a:chExt cx="0" cy="0"/>
-        </a:xfrm>
-      </p:grpSpPr>
-      <p:sp>
-        <p:nvSpPr>
-          <p:cNvPr id="2" name="Slide Image Placeholder 1"/>
-          <p:cNvSpPr>
-            <a:spLocks noGrp="1" noRot="1" noChangeAspect="1"/>
-          </p:cNvSpPr>
-          <p:nvPr>
-            <p:ph type="sldImg"/>
-          </p:nvPr>
-        </p:nvSpPr>
-        <p:spPr/>
-      </p:sp>
-      <p:sp>
-        <p:nvSpPr>
-          <p:cNvPr id="3" name="Notes Placeholder 2"/>
-          <p:cNvSpPr>
-            <a:spLocks noGrp="1"/>
-          </p:cNvSpPr>
-          <p:nvPr>
-            <p:ph type="body" idx="1"/>
-          </p:nvPr>
-        </p:nvSpPr>
-        <p:spPr/>
-        <p:txBody>
-          <a:bodyPr/>
-          <a:lstStyle/>
-          <a:p>
-            <a:r>
-              <a:rPr lang="en-US" dirty="0"/>
-              <a:t>I complete the second page of the logbook: the matter taught, the evaluation, the homework and the attendance.</a:t>
-            </a:r>
-            <a:endParaRPr lang="en-US" dirty="0"/>
-          </a:p>
-        </p:txBody>
-      </p:sp>
-      <p:sp>
-        <p:nvSpPr>
-          <p:cNvPr id="4" name="Slide Number Placeholder 3"/>
-          <p:cNvSpPr>
-            <a:spLocks noGrp="1"/>
-          </p:cNvSpPr>
-          <p:nvPr>
-            <p:ph type="sldNum" sz="quarter" idx="10"/>
-          </p:nvPr>
-        </p:nvSpPr>
-        <p:spPr/>
-        <p:txBody>
-          <a:bodyPr/>
-          <a:lstStyle/>
-          <a:p>
-            <a:fld id="{F7021451-1387-4CA6-816F-3879F97B5CBC}" type="slidenum">
-              <a:rPr lang="en-US"/>
-              <a:t>63</a:t>
-            </a:fld>
-            <a:endParaRPr lang="en-US"/>
-          </a:p>
-        </p:txBody>
-      </p:sp>
-    </p:spTree>
-    <p:extLst>
-      <p:ext uri="{BB962C8B-B14F-4D97-AF65-F5344CB8AC3E}">
-        <p14:creationId xmlns:p14="http://schemas.microsoft.com/office/powerpoint/2010/main" val="1024086991"/>
-      </p:ext>
-    </p:extLst>
-  </p:cSld>
-  <p:clrMapOvr>
-    <a:masterClrMapping/>
-  </p:clrMapOvr>
-</p:notes>
-</file>
-
-<file path=ppt/notesSlides/notesSlide64.xml><?xml version="1.0" encoding="utf-8"?>
-<p:notes xmlns:a="http://schemas.openxmlformats.org/drawingml/2006/main" xmlns:r="http://schemas.openxmlformats.org/officeDocument/2006/relationships" xmlns:p="http://schemas.openxmlformats.org/presentationml/2006/main">
-  <p:cSld>
-    <p:spTree>
-      <p:nvGrpSpPr>
-        <p:cNvPr id="1" name=""/>
-        <p:cNvGrpSpPr/>
-        <p:nvPr/>
-      </p:nvGrpSpPr>
-      <p:grpSpPr>
-        <a:xfrm>
-          <a:off x="0" y="0"/>
-          <a:ext cx="0" cy="0"/>
-          <a:chOff x="0" y="0"/>
-          <a:chExt cx="0" cy="0"/>
-        </a:xfrm>
-      </p:grpSpPr>
-      <p:sp>
-        <p:nvSpPr>
-          <p:cNvPr id="2" name="Slide Image Placeholder 1"/>
-          <p:cNvSpPr>
-            <a:spLocks noGrp="1" noRot="1" noChangeAspect="1"/>
-          </p:cNvSpPr>
-          <p:nvPr>
-            <p:ph type="sldImg"/>
-          </p:nvPr>
-        </p:nvSpPr>
-        <p:spPr/>
-      </p:sp>
-      <p:sp>
-        <p:nvSpPr>
-          <p:cNvPr id="3" name="Notes Placeholder 2"/>
-          <p:cNvSpPr>
-            <a:spLocks noGrp="1"/>
-          </p:cNvSpPr>
-          <p:nvPr>
-            <p:ph type="body" idx="1"/>
-          </p:nvPr>
-        </p:nvSpPr>
-        <p:spPr/>
-        <p:txBody>
-          <a:bodyPr/>
-          <a:lstStyle/>
-          <a:p>
-            <a:r>
-              <a:rPr lang="en-US" dirty="0"/>
-              <a:t>This slide is for me, the teacher: it gives the timing of the lesson and what to do if the projector is not available.</a:t>
-            </a:r>
-            <a:endParaRPr lang="en-US" dirty="0"/>
-          </a:p>
-        </p:txBody>
-      </p:sp>
-      <p:sp>
-        <p:nvSpPr>
-          <p:cNvPr id="4" name="Slide Number Placeholder 3"/>
-          <p:cNvSpPr>
-            <a:spLocks noGrp="1"/>
-          </p:cNvSpPr>
-          <p:nvPr>
-            <p:ph type="sldNum" sz="quarter" idx="10"/>
-          </p:nvPr>
-        </p:nvSpPr>
-        <p:spPr/>
-        <p:txBody>
-          <a:bodyPr/>
-          <a:lstStyle/>
-          <a:p>
-            <a:fld id="{F7021451-1387-4CA6-816F-3879F97B5CBC}" type="slidenum">
-              <a:rPr lang="en-US"/>
-              <a:t>64</a:t>
-            </a:fld>
-            <a:endParaRPr lang="en-US"/>
-          </a:p>
-        </p:txBody>
-      </p:sp>
-    </p:spTree>
-    <p:extLst>
-      <p:ext uri="{BB962C8B-B14F-4D97-AF65-F5344CB8AC3E}">
-        <p14:creationId xmlns:p14="http://schemas.microsoft.com/office/powerpoint/2010/main" val="1024086991"/>
-      </p:ext>
-    </p:extLst>
-  </p:cSld>
-  <p:clrMapOvr>
-    <a:masterClrMapping/>
-  </p:clrMapOvr>
-</p:notes>
-</file>
-
-<file path=ppt/notesSlides/notesSlide65.xml><?xml version="1.0" encoding="utf-8"?>
-<p:notes xmlns:a="http://schemas.openxmlformats.org/drawingml/2006/main" xmlns:r="http://schemas.openxmlformats.org/officeDocument/2006/relationships" xmlns:p="http://schemas.openxmlformats.org/presentationml/2006/main">
-  <p:cSld>
-    <p:spTree>
-      <p:nvGrpSpPr>
-        <p:cNvPr id="1" name=""/>
-        <p:cNvGrpSpPr/>
-        <p:nvPr/>
-      </p:nvGrpSpPr>
-      <p:grpSpPr>
-        <a:xfrm>
-          <a:off x="0" y="0"/>
-          <a:ext cx="0" cy="0"/>
-          <a:chOff x="0" y="0"/>
-          <a:chExt cx="0" cy="0"/>
-        </a:xfrm>
-      </p:grpSpPr>
-      <p:sp>
-        <p:nvSpPr>
-          <p:cNvPr id="2" name="Slide Image Placeholder 1"/>
-          <p:cNvSpPr>
-            <a:spLocks noGrp="1" noRot="1" noChangeAspect="1"/>
-          </p:cNvSpPr>
-          <p:nvPr>
-            <p:ph type="sldImg"/>
-          </p:nvPr>
-        </p:nvSpPr>
-        <p:spPr/>
-      </p:sp>
-      <p:sp>
-        <p:nvSpPr>
-          <p:cNvPr id="3" name="Notes Placeholder 2"/>
-          <p:cNvSpPr>
-            <a:spLocks noGrp="1"/>
-          </p:cNvSpPr>
-          <p:nvPr>
-            <p:ph type="body" idx="1"/>
-          </p:nvPr>
-        </p:nvSpPr>
-        <p:spPr/>
-        <p:txBody>
-          <a:bodyPr/>
-          <a:lstStyle/>
-          <a:p>
-            <a:r>
-              <a:rPr lang="en-US" dirty="0"/>
-              <a:t>These are the references and picture credits used to prepare this lesson.</a:t>
-            </a:r>
-            <a:endParaRPr lang="en-US" dirty="0"/>
-          </a:p>
-        </p:txBody>
-      </p:sp>
-      <p:sp>
-        <p:nvSpPr>
-          <p:cNvPr id="4" name="Slide Number Placeholder 3"/>
-          <p:cNvSpPr>
-            <a:spLocks noGrp="1"/>
-          </p:cNvSpPr>
-          <p:nvPr>
-            <p:ph type="sldNum" sz="quarter" idx="10"/>
-          </p:nvPr>
-        </p:nvSpPr>
-        <p:spPr/>
-        <p:txBody>
-          <a:bodyPr/>
-          <a:lstStyle/>
-          <a:p>
-            <a:fld id="{F7021451-1387-4CA6-816F-3879F97B5CBC}" type="slidenum">
-              <a:rPr lang="en-US"/>
-              <a:t>65</a:t>
             </a:fld>
             <a:endParaRPr lang="en-US"/>
           </a:p>
@@ -15746,7 +15479,7 @@
         <p:spPr>
           <a:xfrm>
             <a:off x="365760" y="1783080"/>
-            <a:ext cx="4846320" cy="4617720"/>
+            <a:ext cx="6035040" cy="4617720"/>
           </a:xfrm>
           <a:prstGeom prst="rect">
             <a:avLst/>
@@ -15773,7 +15506,7 @@
                 <a:ea typeface="Times New Roman" pitchFamily="34" charset="-122"/>
                 <a:cs typeface="Times New Roman" pitchFamily="34" charset="-120"/>
               </a:rPr>
-              <a:t>The main mapping techniques are the following:</a:t>
+              <a:t>Population is mapped with the following techniques:</a:t>
             </a:r>
             <a:endParaRPr lang="en-US" sz="3200" dirty="0"/>
           </a:p>
@@ -15810,7 +15543,7 @@
                 <a:ea typeface="Times New Roman" pitchFamily="34" charset="-122"/>
                 <a:cs typeface="Times New Roman" pitchFamily="34" charset="-120"/>
               </a:rPr>
-              <a:t>Each area is shaded according to its density, with darker shades for higher densities, as on a map of the regions of Cameroon.</a:t>
+              <a:t>Each administrative area is shaded according to its density, with darker shades for higher densities. The map of the regions of Cameroon by density is an example.</a:t>
             </a:r>
             <a:endParaRPr lang="en-US" sz="3200" dirty="0"/>
           </a:p>
@@ -15832,8 +15565,8 @@
         </p:blipFill>
         <p:spPr>
           <a:xfrm>
-            <a:off x="5349240" y="2253310"/>
-            <a:ext cx="6659575" cy="3329788"/>
+            <a:off x="6537960" y="2550490"/>
+            <a:ext cx="5470855" cy="2735428"/>
           </a:xfrm>
           <a:prstGeom prst="rect">
             <a:avLst/>
@@ -15848,8 +15581,8 @@
         </p:nvSpPr>
         <p:spPr>
           <a:xfrm>
-            <a:off x="5349240" y="6089904"/>
-            <a:ext cx="6659575" cy="347472"/>
+            <a:off x="6537960" y="6089904"/>
+            <a:ext cx="5470855" cy="347472"/>
           </a:xfrm>
           <a:prstGeom prst="rect">
             <a:avLst/>
@@ -16280,7 +16013,7 @@
         <p:spPr>
           <a:xfrm>
             <a:off x="365760" y="1783080"/>
-            <a:ext cx="4846320" cy="4617720"/>
+            <a:ext cx="6035040" cy="4617720"/>
           </a:xfrm>
           <a:prstGeom prst="rect">
             <a:avLst/>
@@ -16324,7 +16057,7 @@
                 <a:ea typeface="Times New Roman" pitchFamily="34" charset="-122"/>
                 <a:cs typeface="Times New Roman" pitchFamily="34" charset="-120"/>
               </a:rPr>
-              <a:t>Lines join places of equal density, like contour lines, and show gradual change across an area.</a:t>
+              <a:t>Lines join places of equal density, like contour lines on a relief map. They show gradual changes across an area without following boundaries.</a:t>
             </a:r>
             <a:endParaRPr lang="en-US" sz="3600" dirty="0"/>
           </a:p>
@@ -16346,8 +16079,8 @@
         </p:blipFill>
         <p:spPr>
           <a:xfrm>
-            <a:off x="5349240" y="2461422"/>
-            <a:ext cx="6659575" cy="2913564"/>
+            <a:off x="6537960" y="2721454"/>
+            <a:ext cx="5470855" cy="2393499"/>
           </a:xfrm>
           <a:prstGeom prst="rect">
             <a:avLst/>
@@ -16362,8 +16095,8 @@
         </p:nvSpPr>
         <p:spPr>
           <a:xfrm>
-            <a:off x="5349240" y="6089904"/>
-            <a:ext cx="6659575" cy="347472"/>
+            <a:off x="6537960" y="6089904"/>
+            <a:ext cx="5470855" cy="347472"/>
           </a:xfrm>
           <a:prstGeom prst="rect">
             <a:avLst/>
@@ -16555,7 +16288,7 @@
         <p:spPr>
           <a:xfrm>
             <a:off x="365760" y="1783080"/>
-            <a:ext cx="4846320" cy="4617720"/>
+            <a:ext cx="6035040" cy="4617720"/>
           </a:xfrm>
           <a:prstGeom prst="rect">
             <a:avLst/>
@@ -16599,7 +16332,7 @@
                 <a:ea typeface="Times New Roman" pitchFamily="34" charset="-122"/>
                 <a:cs typeface="Times New Roman" pitchFamily="34" charset="-120"/>
               </a:rPr>
-              <a:t>Each dot represents a fixed number of people (for example 10,000), so clusters of dots show dense areas.</a:t>
+              <a:t>Each dot represents a fixed number of people, for example 10,000, and is placed where they live. Clusters of dots show densely populated areas.</a:t>
             </a:r>
             <a:endParaRPr lang="en-US" sz="3600" dirty="0"/>
           </a:p>
@@ -16621,8 +16354,8 @@
         </p:blipFill>
         <p:spPr>
           <a:xfrm>
-            <a:off x="5349240" y="2253310"/>
-            <a:ext cx="6659575" cy="3329788"/>
+            <a:off x="6537960" y="2550490"/>
+            <a:ext cx="5470855" cy="2735428"/>
           </a:xfrm>
           <a:prstGeom prst="rect">
             <a:avLst/>
@@ -16637,8 +16370,8 @@
         </p:nvSpPr>
         <p:spPr>
           <a:xfrm>
-            <a:off x="5349240" y="6089904"/>
-            <a:ext cx="6659575" cy="347472"/>
+            <a:off x="6537960" y="6089904"/>
+            <a:ext cx="5470855" cy="347472"/>
           </a:xfrm>
           <a:prstGeom prst="rect">
             <a:avLst/>
@@ -16830,7 +16563,7 @@
         <p:spPr>
           <a:xfrm>
             <a:off x="365760" y="1783080"/>
-            <a:ext cx="4846320" cy="4617720"/>
+            <a:ext cx="6035040" cy="4617720"/>
           </a:xfrm>
           <a:prstGeom prst="rect">
             <a:avLst/>
@@ -16849,7 +16582,7 @@
               <a:buNone/>
             </a:pPr>
             <a:r>
-              <a:rPr lang="en-US" sz="3200" b="1" dirty="0">
+              <a:rPr lang="en-US" sz="3600" b="1" dirty="0">
                 <a:solidFill>
                   <a:srgbClr val="111111"/>
                 </a:solidFill>
@@ -16866,7 +16599,7 @@
               <a:buNone/>
             </a:pPr>
             <a:r>
-              <a:rPr lang="en-US" sz="3200" dirty="0">
+              <a:rPr lang="en-US" sz="3600" dirty="0">
                 <a:solidFill>
                   <a:srgbClr val="111111"/>
                 </a:solidFill>
@@ -16874,9 +16607,9 @@
                 <a:ea typeface="Times New Roman" pitchFamily="34" charset="-122"/>
                 <a:cs typeface="Times New Roman" pitchFamily="34" charset="-120"/>
               </a:rPr>
-              <a:t>Circles or squares are drawn with an area proportional to the population of each town, so the radius is proportional to the square root of the value.</a:t>
-            </a:r>
-            <a:endParaRPr lang="en-US" sz="3200" dirty="0"/>
+              <a:t>Circles or squares are drawn with an area proportional to the population of each town. The radius is therefore proportional to the square root of the population.</a:t>
+            </a:r>
+            <a:endParaRPr lang="en-US" sz="3600" dirty="0"/>
           </a:p>
         </p:txBody>
       </p:sp>
@@ -16896,8 +16629,8 @@
         </p:blipFill>
         <p:spPr>
           <a:xfrm>
-            <a:off x="5349240" y="2617506"/>
-            <a:ext cx="6659575" cy="2601397"/>
+            <a:off x="6537960" y="2849678"/>
+            <a:ext cx="5470855" cy="2137053"/>
           </a:xfrm>
           <a:prstGeom prst="rect">
             <a:avLst/>
@@ -16912,8 +16645,8 @@
         </p:nvSpPr>
         <p:spPr>
           <a:xfrm>
-            <a:off x="5349240" y="6089904"/>
-            <a:ext cx="6659575" cy="347472"/>
+            <a:off x="6537960" y="6089904"/>
+            <a:ext cx="5470855" cy="347472"/>
           </a:xfrm>
           <a:prstGeom prst="rect">
             <a:avLst/>
@@ -17090,7 +16823,7 @@
                 <a:ea typeface="Times New Roman" pitchFamily="34" charset="-122"/>
                 <a:cs typeface="Times New Roman" pitchFamily="34" charset="-120"/>
               </a:rPr>
-              <a:t>2. Other Methods Showing Unevenness</a:t>
+              <a:t>2. Showing Uneven Distribution</a:t>
             </a:r>
             <a:endParaRPr lang="en-US" sz="3600" dirty="0"/>
           </a:p>
@@ -17105,7 +16838,7 @@
         <p:spPr>
           <a:xfrm>
             <a:off x="365760" y="1783080"/>
-            <a:ext cx="4846320" cy="4617720"/>
+            <a:ext cx="6035040" cy="4617720"/>
           </a:xfrm>
           <a:prstGeom prst="rect">
             <a:avLst/>
@@ -17124,7 +16857,7 @@
               <a:buNone/>
             </a:pPr>
             <a:r>
-              <a:rPr lang="en-US" sz="2800" i="1" dirty="0">
+              <a:rPr lang="en-US" sz="3000" i="1" dirty="0">
                 <a:solidFill>
                   <a:srgbClr val="111111"/>
                 </a:solidFill>
@@ -17132,9 +16865,9 @@
                 <a:ea typeface="Times New Roman" pitchFamily="34" charset="-122"/>
                 <a:cs typeface="Times New Roman" pitchFamily="34" charset="-120"/>
               </a:rPr>
-              <a:t>The other methods showing the unevenness of distribution are the following:</a:t>
-            </a:r>
-            <a:endParaRPr lang="en-US" sz="2800" dirty="0"/>
+              <a:t>The unevenness of distribution is shown with the following methods:</a:t>
+            </a:r>
+            <a:endParaRPr lang="en-US" sz="3000" dirty="0"/>
           </a:p>
           <a:p>
             <a:pPr algn="l" indent="0" marL="0">
@@ -17144,7 +16877,7 @@
               <a:buNone/>
             </a:pPr>
             <a:r>
-              <a:rPr lang="en-US" sz="2800" b="1" dirty="0">
+              <a:rPr lang="en-US" sz="3000" b="1" dirty="0">
                 <a:solidFill>
                   <a:srgbClr val="111111"/>
                 </a:solidFill>
@@ -17152,7 +16885,7 @@
                 <a:ea typeface="Times New Roman" pitchFamily="34" charset="-122"/>
                 <a:cs typeface="Times New Roman" pitchFamily="34" charset="-120"/>
               </a:rPr>
-              <a:t>The Lorenz curve: </a:t>
+              <a:t>Constructing the Lorenz curve: </a:t>
             </a:r>
             <a:pPr algn="l" indent="0" marL="0">
               <a:spcAft>
@@ -17161,7 +16894,7 @@
               <a:buNone/>
             </a:pPr>
             <a:r>
-              <a:rPr lang="en-US" sz="2800" dirty="0">
+              <a:rPr lang="en-US" sz="3000" dirty="0">
                 <a:solidFill>
                   <a:srgbClr val="111111"/>
                 </a:solidFill>
@@ -17169,9 +16902,9 @@
                 <a:ea typeface="Times New Roman" pitchFamily="34" charset="-122"/>
                 <a:cs typeface="Times New Roman" pitchFamily="34" charset="-120"/>
               </a:rPr>
-              <a:t>Areas are ranked from least to most dense, and the cumulative % of population is plotted against the cumulative % of area.</a:t>
-            </a:r>
-            <a:endParaRPr lang="en-US" sz="2800" dirty="0"/>
+              <a:t>Areas are ranked from the least to the most dense, and their percentages of population and area are added up. The cumulative % of population is then plotted against the cumulative % of area.</a:t>
+            </a:r>
+            <a:endParaRPr lang="en-US" sz="3000" dirty="0"/>
           </a:p>
         </p:txBody>
       </p:sp>
@@ -17191,8 +16924,8 @@
         </p:blipFill>
         <p:spPr>
           <a:xfrm>
-            <a:off x="5349240" y="2409394"/>
-            <a:ext cx="6659575" cy="3017620"/>
+            <a:off x="6537960" y="2678713"/>
+            <a:ext cx="5470855" cy="2478981"/>
           </a:xfrm>
           <a:prstGeom prst="rect">
             <a:avLst/>
@@ -17207,8 +16940,8 @@
         </p:nvSpPr>
         <p:spPr>
           <a:xfrm>
-            <a:off x="5349240" y="6089904"/>
-            <a:ext cx="6659575" cy="347472"/>
+            <a:off x="6537960" y="6089904"/>
+            <a:ext cx="5470855" cy="347472"/>
           </a:xfrm>
           <a:prstGeom prst="rect">
             <a:avLst/>
@@ -17232,7 +16965,7 @@
                 <a:ea typeface="Times New Roman" pitchFamily="34" charset="-122"/>
                 <a:cs typeface="Times New Roman" pitchFamily="34" charset="-120"/>
               </a:rPr>
-              <a:t>Illustration: a Lorenz curve for Cameroon</a:t>
+              <a:t>Illustration: a Lorenz curve</a:t>
             </a:r>
             <a:endParaRPr lang="en-US" sz="1600" dirty="0"/>
           </a:p>
@@ -17409,7 +17142,7 @@
                 <a:ea typeface="Times New Roman" pitchFamily="34" charset="-122"/>
                 <a:cs typeface="Times New Roman" pitchFamily="34" charset="-120"/>
               </a:rPr>
-              <a:t>2. Other Methods Showing Unevenness</a:t>
+              <a:t>2. Showing Uneven Distribution</a:t>
             </a:r>
             <a:endParaRPr lang="en-US" sz="3600" dirty="0"/>
           </a:p>
@@ -17468,7 +17201,7 @@
                 <a:ea typeface="Times New Roman" pitchFamily="34" charset="-122"/>
                 <a:cs typeface="Times New Roman" pitchFamily="34" charset="-120"/>
               </a:rPr>
-              <a:t>The diagonal shows a perfectly even distribution, and the further the curve lies from it, the more uneven the distribution.</a:t>
+              <a:t>The diagonal line shows a perfectly even distribution. The further the curve lies from the diagonal, the more uneven the distribution.</a:t>
             </a:r>
             <a:endParaRPr lang="en-US" sz="4000" dirty="0"/>
           </a:p>
@@ -17621,7 +17354,7 @@
                 <a:ea typeface="Times New Roman" pitchFamily="34" charset="-122"/>
                 <a:cs typeface="Times New Roman" pitchFamily="34" charset="-120"/>
               </a:rPr>
-              <a:t>2. Other Methods Showing Unevenness</a:t>
+              <a:t>2. Showing Uneven Distribution</a:t>
             </a:r>
             <a:endParaRPr lang="en-US" sz="3600" dirty="0"/>
           </a:p>
@@ -17636,7 +17369,7 @@
         <p:spPr>
           <a:xfrm>
             <a:off x="365760" y="1783080"/>
-            <a:ext cx="4846320" cy="4617720"/>
+            <a:ext cx="6035040" cy="4617720"/>
           </a:xfrm>
           <a:prstGeom prst="rect">
             <a:avLst/>
@@ -17655,7 +17388,7 @@
               <a:buNone/>
             </a:pPr>
             <a:r>
-              <a:rPr lang="en-US" sz="3600" b="1" dirty="0">
+              <a:rPr lang="en-US" sz="3400" b="1" dirty="0">
                 <a:solidFill>
                   <a:srgbClr val="111111"/>
                 </a:solidFill>
@@ -17672,7 +17405,7 @@
               <a:buNone/>
             </a:pPr>
             <a:r>
-              <a:rPr lang="en-US" sz="3600" dirty="0">
+              <a:rPr lang="en-US" sz="3400" dirty="0">
                 <a:solidFill>
                   <a:srgbClr val="111111"/>
                 </a:solidFill>
@@ -17680,9 +17413,9 @@
                 <a:ea typeface="Times New Roman" pitchFamily="34" charset="-122"/>
                 <a:cs typeface="Times New Roman" pitchFamily="34" charset="-120"/>
               </a:rPr>
-              <a:t>Density is plotted against distance from a city centre or from the coast, and it usually falls quickly outwards.</a:t>
-            </a:r>
-            <a:endParaRPr lang="en-US" sz="3600" dirty="0"/>
+              <a:t>Density is plotted against distance from a city centre or from the coast, and it usually falls quickly outwards. In Yaoundé, for example, density is very high near the centre and falls towards the outskirts.</a:t>
+            </a:r>
+            <a:endParaRPr lang="en-US" sz="3400" dirty="0"/>
           </a:p>
         </p:txBody>
       </p:sp>
@@ -17702,8 +17435,8 @@
         </p:blipFill>
         <p:spPr>
           <a:xfrm>
-            <a:off x="5349240" y="2461422"/>
-            <a:ext cx="6659575" cy="2913564"/>
+            <a:off x="6537960" y="2721454"/>
+            <a:ext cx="5470855" cy="2393499"/>
           </a:xfrm>
           <a:prstGeom prst="rect">
             <a:avLst/>
@@ -17718,8 +17451,8 @@
         </p:nvSpPr>
         <p:spPr>
           <a:xfrm>
-            <a:off x="5349240" y="6089904"/>
-            <a:ext cx="6659575" cy="347472"/>
+            <a:off x="6537960" y="6089904"/>
+            <a:ext cx="5470855" cy="347472"/>
           </a:xfrm>
           <a:prstGeom prst="rect">
             <a:avLst/>
@@ -17743,7 +17476,7 @@
                 <a:ea typeface="Times New Roman" pitchFamily="34" charset="-122"/>
                 <a:cs typeface="Times New Roman" pitchFamily="34" charset="-120"/>
               </a:rPr>
-              <a:t>Illustration: a density lapse graph</a:t>
+              <a:t>Illustration: a density lapse rate</a:t>
             </a:r>
             <a:endParaRPr lang="en-US" sz="1600" dirty="0"/>
           </a:p>
@@ -17878,7 +17611,7 @@
         <p:spPr>
           <a:xfrm>
             <a:off x="0" y="658368"/>
-            <a:ext cx="5120640" cy="5833872"/>
+            <a:ext cx="2468880" cy="5833872"/>
           </a:xfrm>
           <a:prstGeom prst="rect">
             <a:avLst/>
@@ -17893,8 +17626,8 @@
         </p:nvSpPr>
         <p:spPr>
           <a:xfrm>
-            <a:off x="5349240" y="1005840"/>
-            <a:ext cx="6522415" cy="731520"/>
+            <a:off x="2697480" y="1005840"/>
+            <a:ext cx="9174175" cy="731520"/>
           </a:xfrm>
           <a:prstGeom prst="rect">
             <a:avLst/>
@@ -17920,7 +17653,7 @@
                 <a:ea typeface="Times New Roman" pitchFamily="34" charset="-122"/>
                 <a:cs typeface="Times New Roman" pitchFamily="34" charset="-120"/>
               </a:rPr>
-              <a:t>2. Other Methods Showing Unevenness</a:t>
+              <a:t>3. Assessment of the Techniques</a:t>
             </a:r>
             <a:endParaRPr lang="en-US" sz="3600" dirty="0"/>
           </a:p>
@@ -17934,8 +17667,8 @@
         </p:nvSpPr>
         <p:spPr>
           <a:xfrm>
-            <a:off x="5349240" y="1783080"/>
-            <a:ext cx="6522415" cy="4663440"/>
+            <a:off x="2697480" y="1783080"/>
+            <a:ext cx="9174175" cy="4663440"/>
           </a:xfrm>
           <a:prstGeom prst="rect">
             <a:avLst/>
@@ -17954,7 +17687,7 @@
               <a:buNone/>
             </a:pPr>
             <a:r>
-              <a:rPr lang="en-US" sz="4000" b="1" dirty="0">
+              <a:rPr lang="en-US" sz="4000" i="1" dirty="0">
                 <a:solidFill>
                   <a:srgbClr val="111111"/>
                 </a:solidFill>
@@ -17962,8 +17695,11 @@
                 <a:ea typeface="Times New Roman" pitchFamily="34" charset="-122"/>
                 <a:cs typeface="Times New Roman" pitchFamily="34" charset="-120"/>
               </a:rPr>
-              <a:t>Example: </a:t>
-            </a:r>
+              <a:t>The techniques have the following advantages and disadvantages:</a:t>
+            </a:r>
+            <a:endParaRPr lang="en-US" sz="4000" dirty="0"/>
+          </a:p>
+          <a:p>
             <a:pPr algn="l" indent="0" marL="0">
               <a:spcAft>
                 <a:spcPts val="800"/>
@@ -17971,7 +17707,7 @@
               <a:buNone/>
             </a:pPr>
             <a:r>
-              <a:rPr lang="en-US" sz="4000" dirty="0">
+              <a:rPr lang="en-US" sz="4000" b="1" dirty="0">
                 <a:solidFill>
                   <a:srgbClr val="111111"/>
                 </a:solidFill>
@@ -17979,7 +17715,24 @@
                 <a:ea typeface="Times New Roman" pitchFamily="34" charset="-122"/>
                 <a:cs typeface="Times New Roman" pitchFamily="34" charset="-120"/>
               </a:rPr>
-              <a:t>In a city like Yaoundé, density is very high near the centre and falls towards the outskirts.</a:t>
+              <a:t>Choropleth map: </a:t>
+            </a:r>
+            <a:pPr algn="l" indent="0" marL="0">
+              <a:spcAft>
+                <a:spcPts val="800"/>
+              </a:spcAft>
+              <a:buNone/>
+            </a:pPr>
+            <a:r>
+              <a:rPr lang="en-US" sz="4000" dirty="0">
+                <a:solidFill>
+                  <a:srgbClr val="111111"/>
+                </a:solidFill>
+                <a:latin typeface="Times New Roman" pitchFamily="34" charset="0"/>
+                <a:ea typeface="Times New Roman" pitchFamily="34" charset="-122"/>
+                <a:cs typeface="Times New Roman" pitchFamily="34" charset="-120"/>
+              </a:rPr>
+              <a:t>It is easy to draw and read and allows areas to be compared quickly. However, it hides differences inside each area and depends on administrative boundaries.</a:t>
             </a:r>
             <a:endParaRPr lang="en-US" sz="4000" dirty="0"/>
           </a:p>
@@ -18190,7 +17943,7 @@
               <a:buNone/>
             </a:pPr>
             <a:r>
-              <a:rPr lang="en-US" sz="4000" i="1" dirty="0">
+              <a:rPr lang="en-US" sz="4000" b="1" dirty="0">
                 <a:solidFill>
                   <a:srgbClr val="111111"/>
                 </a:solidFill>
@@ -18198,11 +17951,8 @@
                 <a:ea typeface="Times New Roman" pitchFamily="34" charset="-122"/>
                 <a:cs typeface="Times New Roman" pitchFamily="34" charset="-120"/>
               </a:rPr>
-              <a:t>The advantages and disadvantages of the techniques are the following:</a:t>
-            </a:r>
-            <a:endParaRPr lang="en-US" sz="4000" dirty="0"/>
-          </a:p>
-          <a:p>
+              <a:t>Isopleth map: </a:t>
+            </a:r>
             <a:pPr algn="l" indent="0" marL="0">
               <a:spcAft>
                 <a:spcPts val="800"/>
@@ -18210,7 +17960,7 @@
               <a:buNone/>
             </a:pPr>
             <a:r>
-              <a:rPr lang="en-US" sz="4000" b="1" dirty="0">
+              <a:rPr lang="en-US" sz="4000" dirty="0">
                 <a:solidFill>
                   <a:srgbClr val="111111"/>
                 </a:solidFill>
@@ -18218,28 +17968,7 @@
                 <a:ea typeface="Times New Roman" pitchFamily="34" charset="-122"/>
                 <a:cs typeface="Times New Roman" pitchFamily="34" charset="-120"/>
               </a:rPr>
-              <a:t>Choropleth map:</a:t>
-            </a:r>
-            <a:endParaRPr lang="en-US" sz="4000" dirty="0"/>
-          </a:p>
-          <a:p>
-            <a:pPr algn="l" marL="342900" indent="-342900">
-              <a:spcAft>
-                <a:spcPts val="800"/>
-              </a:spcAft>
-              <a:buSzPct val="100000"/>
-              <a:buChar char="•"/>
-            </a:pPr>
-            <a:r>
-              <a:rPr lang="en-US" sz="4000" dirty="0">
-                <a:solidFill>
-                  <a:srgbClr val="111111"/>
-                </a:solidFill>
-                <a:latin typeface="Times New Roman" pitchFamily="34" charset="0"/>
-                <a:ea typeface="Times New Roman" pitchFamily="34" charset="-122"/>
-                <a:cs typeface="Times New Roman" pitchFamily="34" charset="-120"/>
-              </a:rPr>
-              <a:t>Advantage: it is easy to read and to compare areas.</a:t>
+              <a:t>It shows gradual changes across a region and is not limited by boundaries. However, it needs many data points and is harder to draw and read.</a:t>
             </a:r>
             <a:endParaRPr lang="en-US" sz="4000" dirty="0"/>
           </a:p>
@@ -18374,7 +18103,7 @@
         <p:spPr>
           <a:xfrm>
             <a:off x="0" y="658368"/>
-            <a:ext cx="3840480" cy="5833872"/>
+            <a:ext cx="2468880" cy="5833872"/>
           </a:xfrm>
           <a:prstGeom prst="rect">
             <a:avLst/>
@@ -18389,8 +18118,8 @@
         </p:nvSpPr>
         <p:spPr>
           <a:xfrm>
-            <a:off x="4069080" y="1005840"/>
-            <a:ext cx="7802575" cy="731520"/>
+            <a:off x="2697480" y="1005840"/>
+            <a:ext cx="9174175" cy="731520"/>
           </a:xfrm>
           <a:prstGeom prst="rect">
             <a:avLst/>
@@ -18416,7 +18145,7 @@
                 <a:ea typeface="Times New Roman" pitchFamily="34" charset="-122"/>
                 <a:cs typeface="Times New Roman" pitchFamily="34" charset="-120"/>
               </a:rPr>
-              <a:t>3. Assessment of the Techniques (continued)</a:t>
+              <a:t>3. Assessment of the Techniques</a:t>
             </a:r>
             <a:endParaRPr lang="en-US" sz="3600" dirty="0"/>
           </a:p>
@@ -18430,8 +18159,8 @@
         </p:nvSpPr>
         <p:spPr>
           <a:xfrm>
-            <a:off x="4069080" y="1783080"/>
-            <a:ext cx="7802575" cy="4663440"/>
+            <a:off x="2697480" y="1783080"/>
+            <a:ext cx="9174175" cy="4663440"/>
           </a:xfrm>
           <a:prstGeom prst="rect">
             <a:avLst/>
@@ -18442,27 +18171,6 @@
         <p:txBody>
           <a:bodyPr wrap="square" lIns="0" tIns="0" rIns="0" bIns="0" rtlCol="0" anchor="t"/>
           <a:lstStyle/>
-          <a:p>
-            <a:pPr algn="l" marL="342900" indent="-342900">
-              <a:spcAft>
-                <a:spcPts val="800"/>
-              </a:spcAft>
-              <a:buSzPct val="100000"/>
-              <a:buChar char="•"/>
-            </a:pPr>
-            <a:r>
-              <a:rPr lang="en-US" sz="4000" dirty="0">
-                <a:solidFill>
-                  <a:srgbClr val="111111"/>
-                </a:solidFill>
-                <a:latin typeface="Times New Roman" pitchFamily="34" charset="0"/>
-                <a:ea typeface="Times New Roman" pitchFamily="34" charset="-122"/>
-                <a:cs typeface="Times New Roman" pitchFamily="34" charset="-120"/>
-              </a:rPr>
-              <a:t>Disadvantage: it hides differences inside each area and depends on administrative boundaries.</a:t>
-            </a:r>
-            <a:endParaRPr lang="en-US" sz="4000" dirty="0"/>
-          </a:p>
           <a:p>
             <a:pPr algn="l" indent="0" marL="0">
               <a:spcAft>
@@ -18479,17 +18187,13 @@
                 <a:ea typeface="Times New Roman" pitchFamily="34" charset="-122"/>
                 <a:cs typeface="Times New Roman" pitchFamily="34" charset="-120"/>
               </a:rPr>
-              <a:t>Isopleth map:</a:t>
-            </a:r>
-            <a:endParaRPr lang="en-US" sz="4000" dirty="0"/>
-          </a:p>
-          <a:p>
-            <a:pPr algn="l" marL="342900" indent="-342900">
+              <a:t>Dot map and proportional symbols: </a:t>
+            </a:r>
+            <a:pPr algn="l" indent="0" marL="0">
               <a:spcAft>
                 <a:spcPts val="800"/>
               </a:spcAft>
-              <a:buSzPct val="100000"/>
-              <a:buChar char="•"/>
+              <a:buNone/>
             </a:pPr>
             <a:r>
               <a:rPr lang="en-US" sz="4000" dirty="0">
@@ -18500,7 +18204,7 @@
                 <a:ea typeface="Times New Roman" pitchFamily="34" charset="-122"/>
                 <a:cs typeface="Times New Roman" pitchFamily="34" charset="-120"/>
               </a:rPr>
-              <a:t>Advantage: it shows gradual changes across a region.</a:t>
+              <a:t>Dot maps show the real pattern and clusters of people, and proportional symbols are easy to compare at a glance. However, dots merge and symbols overlap in crowded areas, so exact numbers are hard to read.</a:t>
             </a:r>
             <a:endParaRPr lang="en-US" sz="4000" dirty="0"/>
           </a:p>
@@ -18677,7 +18381,7 @@
                 <a:ea typeface="Times New Roman" pitchFamily="34" charset="-122"/>
                 <a:cs typeface="Times New Roman" pitchFamily="34" charset="-120"/>
               </a:rPr>
-              <a:t>3. Assessment of the Techniques (continued)</a:t>
+              <a:t>3. Assessment of the Techniques</a:t>
             </a:r>
             <a:endParaRPr lang="en-US" sz="3600" dirty="0"/>
           </a:p>
@@ -18703,27 +18407,6 @@
         <p:txBody>
           <a:bodyPr wrap="square" lIns="0" tIns="0" rIns="0" bIns="0" rtlCol="0" anchor="t"/>
           <a:lstStyle/>
-          <a:p>
-            <a:pPr algn="l" marL="342900" indent="-342900">
-              <a:spcAft>
-                <a:spcPts val="800"/>
-              </a:spcAft>
-              <a:buSzPct val="100000"/>
-              <a:buChar char="•"/>
-            </a:pPr>
-            <a:r>
-              <a:rPr lang="en-US" sz="4000" dirty="0">
-                <a:solidFill>
-                  <a:srgbClr val="111111"/>
-                </a:solidFill>
-                <a:latin typeface="Times New Roman" pitchFamily="34" charset="0"/>
-                <a:ea typeface="Times New Roman" pitchFamily="34" charset="-122"/>
-                <a:cs typeface="Times New Roman" pitchFamily="34" charset="-120"/>
-              </a:rPr>
-              <a:t>Disadvantage: it needs many data points and is harder to read.</a:t>
-            </a:r>
-            <a:endParaRPr lang="en-US" sz="4000" dirty="0"/>
-          </a:p>
           <a:p>
             <a:pPr algn="l" indent="0" marL="0">
               <a:spcAft>
@@ -18740,17 +18423,13 @@
                 <a:ea typeface="Times New Roman" pitchFamily="34" charset="-122"/>
                 <a:cs typeface="Times New Roman" pitchFamily="34" charset="-120"/>
               </a:rPr>
-              <a:t>Dot map:</a:t>
-            </a:r>
-            <a:endParaRPr lang="en-US" sz="4000" dirty="0"/>
-          </a:p>
-          <a:p>
-            <a:pPr algn="l" marL="342900" indent="-342900">
+              <a:t>Lorenz curve and lapse rate: </a:t>
+            </a:r>
+            <a:pPr algn="l" indent="0" marL="0">
               <a:spcAft>
                 <a:spcPts val="800"/>
               </a:spcAft>
-              <a:buSzPct val="100000"/>
-              <a:buChar char="•"/>
+              <a:buNone/>
             </a:pPr>
             <a:r>
               <a:rPr lang="en-US" sz="4000" dirty="0">
@@ -18761,7 +18440,7 @@
                 <a:ea typeface="Times New Roman" pitchFamily="34" charset="-122"/>
                 <a:cs typeface="Times New Roman" pitchFamily="34" charset="-120"/>
               </a:rPr>
-              <a:t>Advantage: it shows the real pattern and clusters of people.</a:t>
+              <a:t>They measure the degree of inequality and the change of density with distance. However, they need detailed data and do not show where people live on a map.</a:t>
             </a:r>
             <a:endParaRPr lang="en-US" sz="4000" dirty="0"/>
           </a:p>
@@ -19092,7 +18771,7 @@
                 <a:ea typeface="Calibri" pitchFamily="34" charset="-122"/>
                 <a:cs typeface="Calibri" pitchFamily="34" charset="-120"/>
               </a:rPr>
-              <a:t>BOARD SUMMARY</a:t>
+              <a:t>FORMATIVE EVALUATION</a:t>
             </a:r>
             <a:endParaRPr lang="en-US" sz="1400" dirty="0"/>
           </a:p>
@@ -19157,7 +18836,7 @@
                 <a:ea typeface="Times New Roman" pitchFamily="34" charset="-122"/>
                 <a:cs typeface="Times New Roman" pitchFamily="34" charset="-120"/>
               </a:rPr>
-              <a:t>3. Assessment of the Techniques (continued)</a:t>
+              <a:t>Evaluation 1</a:t>
             </a:r>
             <a:endParaRPr lang="en-US" sz="3600" dirty="0"/>
           </a:p>
@@ -19183,27 +18862,6 @@
         <p:txBody>
           <a:bodyPr wrap="square" lIns="0" tIns="0" rIns="0" bIns="0" rtlCol="0" anchor="t"/>
           <a:lstStyle/>
-          <a:p>
-            <a:pPr algn="l" marL="342900" indent="-342900">
-              <a:spcAft>
-                <a:spcPts val="800"/>
-              </a:spcAft>
-              <a:buSzPct val="100000"/>
-              <a:buChar char="•"/>
-            </a:pPr>
-            <a:r>
-              <a:rPr lang="en-US" sz="4000" dirty="0">
-                <a:solidFill>
-                  <a:srgbClr val="111111"/>
-                </a:solidFill>
-                <a:latin typeface="Times New Roman" pitchFamily="34" charset="0"/>
-                <a:ea typeface="Times New Roman" pitchFamily="34" charset="-122"/>
-                <a:cs typeface="Times New Roman" pitchFamily="34" charset="-120"/>
-              </a:rPr>
-              <a:t>Disadvantage: dots merge in very dense areas, and exact numbers are hard to count.</a:t>
-            </a:r>
-            <a:endParaRPr lang="en-US" sz="4000" dirty="0"/>
-          </a:p>
           <a:p>
             <a:pPr algn="l" indent="0" marL="0">
               <a:spcAft>
@@ -19212,7 +18870,7 @@
               <a:buNone/>
             </a:pPr>
             <a:r>
-              <a:rPr lang="en-US" sz="4000" b="1" dirty="0">
+              <a:rPr lang="en-US" sz="4000" dirty="0">
                 <a:solidFill>
                   <a:srgbClr val="111111"/>
                 </a:solidFill>
@@ -19220,28 +18878,7 @@
                 <a:ea typeface="Times New Roman" pitchFamily="34" charset="-122"/>
                 <a:cs typeface="Times New Roman" pitchFamily="34" charset="-120"/>
               </a:rPr>
-              <a:t>Proportional symbols:</a:t>
-            </a:r>
-            <a:endParaRPr lang="en-US" sz="4000" dirty="0"/>
-          </a:p>
-          <a:p>
-            <a:pPr algn="l" marL="342900" indent="-342900">
-              <a:spcAft>
-                <a:spcPts val="800"/>
-              </a:spcAft>
-              <a:buSzPct val="100000"/>
-              <a:buChar char="•"/>
-            </a:pPr>
-            <a:r>
-              <a:rPr lang="en-US" sz="4000" dirty="0">
-                <a:solidFill>
-                  <a:srgbClr val="111111"/>
-                </a:solidFill>
-                <a:latin typeface="Times New Roman" pitchFamily="34" charset="0"/>
-                <a:ea typeface="Times New Roman" pitchFamily="34" charset="-122"/>
-                <a:cs typeface="Times New Roman" pitchFamily="34" charset="-120"/>
-              </a:rPr>
-              <a:t>Advantage: sizes are easy to compare at a glance.</a:t>
+              <a:t>Give one advantage and one disadvantage of the dot map.</a:t>
             </a:r>
             <a:endParaRPr lang="en-US" sz="4000" dirty="0"/>
           </a:p>
@@ -19353,7 +18990,7 @@
                 <a:ea typeface="Calibri" pitchFamily="34" charset="-122"/>
                 <a:cs typeface="Calibri" pitchFamily="34" charset="-120"/>
               </a:rPr>
-              <a:t>BOARD SUMMARY</a:t>
+              <a:t>FORMATIVE EVALUATION</a:t>
             </a:r>
             <a:endParaRPr lang="en-US" sz="1400" dirty="0"/>
           </a:p>
@@ -19418,7 +19055,7 @@
                 <a:ea typeface="Times New Roman" pitchFamily="34" charset="-122"/>
                 <a:cs typeface="Times New Roman" pitchFamily="34" charset="-120"/>
               </a:rPr>
-              <a:t>3. Assessment of the Techniques (continued)</a:t>
+              <a:t>Expected Answer</a:t>
             </a:r>
             <a:endParaRPr lang="en-US" sz="3600" dirty="0"/>
           </a:p>
@@ -19444,27 +19081,6 @@
         <p:txBody>
           <a:bodyPr wrap="square" lIns="0" tIns="0" rIns="0" bIns="0" rtlCol="0" anchor="t"/>
           <a:lstStyle/>
-          <a:p>
-            <a:pPr algn="l" marL="342900" indent="-342900">
-              <a:spcAft>
-                <a:spcPts val="800"/>
-              </a:spcAft>
-              <a:buSzPct val="100000"/>
-              <a:buChar char="•"/>
-            </a:pPr>
-            <a:r>
-              <a:rPr lang="en-US" sz="4000" dirty="0">
-                <a:solidFill>
-                  <a:srgbClr val="111111"/>
-                </a:solidFill>
-                <a:latin typeface="Times New Roman" pitchFamily="34" charset="0"/>
-                <a:ea typeface="Times New Roman" pitchFamily="34" charset="-122"/>
-                <a:cs typeface="Times New Roman" pitchFamily="34" charset="-120"/>
-              </a:rPr>
-              <a:t>Disadvantage: symbols overlap in crowded areas and are not precise.</a:t>
-            </a:r>
-            <a:endParaRPr lang="en-US" sz="4000" dirty="0"/>
-          </a:p>
           <a:p>
             <a:pPr algn="l" indent="0" marL="0">
               <a:spcAft>
@@ -19473,7 +19089,7 @@
               <a:buNone/>
             </a:pPr>
             <a:r>
-              <a:rPr lang="en-US" sz="4000" b="1" dirty="0">
+              <a:rPr lang="en-US" sz="4000" dirty="0">
                 <a:solidFill>
                   <a:srgbClr val="111111"/>
                 </a:solidFill>
@@ -19481,28 +19097,7 @@
                 <a:ea typeface="Times New Roman" pitchFamily="34" charset="-122"/>
                 <a:cs typeface="Times New Roman" pitchFamily="34" charset="-120"/>
               </a:rPr>
-              <a:t>Lorenz curve and lapse rate:</a:t>
-            </a:r>
-            <a:endParaRPr lang="en-US" sz="4000" dirty="0"/>
-          </a:p>
-          <a:p>
-            <a:pPr algn="l" marL="342900" indent="-342900">
-              <a:spcAft>
-                <a:spcPts val="800"/>
-              </a:spcAft>
-              <a:buSzPct val="100000"/>
-              <a:buChar char="•"/>
-            </a:pPr>
-            <a:r>
-              <a:rPr lang="en-US" sz="4000" dirty="0">
-                <a:solidFill>
-                  <a:srgbClr val="111111"/>
-                </a:solidFill>
-                <a:latin typeface="Times New Roman" pitchFamily="34" charset="0"/>
-                <a:ea typeface="Times New Roman" pitchFamily="34" charset="-122"/>
-                <a:cs typeface="Times New Roman" pitchFamily="34" charset="-120"/>
-              </a:rPr>
-              <a:t>Advantage: they measure inequality and change with distance.</a:t>
+              <a:t>Advantage: it shows the real pattern of population; disadvantage: dots merge in dense areas.</a:t>
             </a:r>
             <a:endParaRPr lang="en-US" sz="4000" dirty="0"/>
           </a:p>
@@ -19614,7 +19209,7 @@
                 <a:ea typeface="Calibri" pitchFamily="34" charset="-122"/>
                 <a:cs typeface="Calibri" pitchFamily="34" charset="-120"/>
               </a:rPr>
-              <a:t>BOARD SUMMARY</a:t>
+              <a:t>FORMATIVE EVALUATION</a:t>
             </a:r>
             <a:endParaRPr lang="en-US" sz="1400" dirty="0"/>
           </a:p>
@@ -19679,7 +19274,7 @@
                 <a:ea typeface="Times New Roman" pitchFamily="34" charset="-122"/>
                 <a:cs typeface="Times New Roman" pitchFamily="34" charset="-120"/>
               </a:rPr>
-              <a:t>3. Assessment of the Techniques (continued)</a:t>
+              <a:t>Evaluation 2</a:t>
             </a:r>
             <a:endParaRPr lang="en-US" sz="3600" dirty="0"/>
           </a:p>
@@ -19706,12 +19301,11 @@
           <a:bodyPr wrap="square" lIns="0" tIns="0" rIns="0" bIns="0" rtlCol="0" anchor="t"/>
           <a:lstStyle/>
           <a:p>
-            <a:pPr algn="l" marL="342900" indent="-342900">
+            <a:pPr algn="l" indent="0" marL="0">
               <a:spcAft>
                 <a:spcPts val="800"/>
               </a:spcAft>
-              <a:buSzPct val="100000"/>
-              <a:buChar char="•"/>
+              <a:buNone/>
             </a:pPr>
             <a:r>
               <a:rPr lang="en-US" sz="4000" dirty="0">
@@ -19722,7 +19316,7 @@
                 <a:ea typeface="Times New Roman" pitchFamily="34" charset="-122"/>
                 <a:cs typeface="Times New Roman" pitchFamily="34" charset="-120"/>
               </a:rPr>
-              <a:t>Disadvantage: they need detailed data and do not show locations on a map.</a:t>
+              <a:t>What does a Lorenz curve far from the diagonal show?</a:t>
             </a:r>
             <a:endParaRPr lang="en-US" sz="4000" dirty="0"/>
           </a:p>
@@ -19899,7 +19493,7 @@
                 <a:ea typeface="Times New Roman" pitchFamily="34" charset="-122"/>
                 <a:cs typeface="Times New Roman" pitchFamily="34" charset="-120"/>
               </a:rPr>
-              <a:t>Evaluation 1</a:t>
+              <a:t>Expected Answer</a:t>
             </a:r>
             <a:endParaRPr lang="en-US" sz="3600" dirty="0"/>
           </a:p>
@@ -19941,7 +19535,7 @@
                 <a:ea typeface="Times New Roman" pitchFamily="34" charset="-122"/>
                 <a:cs typeface="Times New Roman" pitchFamily="34" charset="-120"/>
               </a:rPr>
-              <a:t>Give one advantage and one disadvantage of the dot map.</a:t>
+              <a:t>A very uneven distribution of the population.</a:t>
             </a:r>
             <a:endParaRPr lang="en-US" sz="4000" dirty="0"/>
           </a:p>
@@ -20053,7 +19647,7 @@
                 <a:ea typeface="Calibri" pitchFamily="34" charset="-122"/>
                 <a:cs typeface="Calibri" pitchFamily="34" charset="-120"/>
               </a:rPr>
-              <a:t>FORMATIVE EVALUATION</a:t>
+              <a:t>REMEDIATION</a:t>
             </a:r>
             <a:endParaRPr lang="en-US" sz="1400" dirty="0"/>
           </a:p>
@@ -20118,7 +19712,7 @@
                 <a:ea typeface="Times New Roman" pitchFamily="34" charset="-122"/>
                 <a:cs typeface="Times New Roman" pitchFamily="34" charset="-120"/>
               </a:rPr>
-              <a:t>Expected Answer</a:t>
+              <a:t>Remediation</a:t>
             </a:r>
             <a:endParaRPr lang="en-US" sz="3600" dirty="0"/>
           </a:p>
@@ -20152,7 +19746,7 @@
               <a:buNone/>
             </a:pPr>
             <a:r>
-              <a:rPr lang="en-US" sz="4000" dirty="0">
+              <a:rPr lang="en-US" sz="4000" b="1" dirty="0">
                 <a:solidFill>
                   <a:srgbClr val="111111"/>
                 </a:solidFill>
@@ -20160,7 +19754,51 @@
                 <a:ea typeface="Times New Roman" pitchFamily="34" charset="-122"/>
                 <a:cs typeface="Times New Roman" pitchFamily="34" charset="-120"/>
               </a:rPr>
-              <a:t>Advantage: it shows the real pattern of population; disadvantage: dots merge in dense areas.</a:t>
+              <a:t>Fill in the blanks:</a:t>
+            </a:r>
+            <a:endParaRPr lang="en-US" sz="4000" dirty="0"/>
+          </a:p>
+          <a:p>
+            <a:pPr algn="l" marL="342900" indent="-342900">
+              <a:spcAft>
+                <a:spcPts val="800"/>
+              </a:spcAft>
+              <a:buSzPct val="100000"/>
+              <a:buFont typeface="+mj-lt"/>
+              <a:buAutoNum type="arabicPeriod" startAt="1"/>
+            </a:pPr>
+            <a:r>
+              <a:rPr lang="en-US" sz="4000" dirty="0">
+                <a:solidFill>
+                  <a:srgbClr val="111111"/>
+                </a:solidFill>
+                <a:latin typeface="Times New Roman" pitchFamily="34" charset="0"/>
+                <a:ea typeface="Times New Roman" pitchFamily="34" charset="-122"/>
+                <a:cs typeface="Times New Roman" pitchFamily="34" charset="-120"/>
+              </a:rPr>
+              <a:t>A map with shades of colour for each region is a ______ map.</a:t>
+            </a:r>
+            <a:endParaRPr lang="en-US" sz="4000" dirty="0"/>
+          </a:p>
+          <a:p>
+            <a:pPr algn="l" marL="342900" indent="-342900">
+              <a:spcAft>
+                <a:spcPts val="800"/>
+              </a:spcAft>
+              <a:buSzPct val="100000"/>
+              <a:buFont typeface="+mj-lt"/>
+              <a:buAutoNum type="arabicPeriod" startAt="1"/>
+            </a:pPr>
+            <a:r>
+              <a:rPr lang="en-US" sz="4000" dirty="0">
+                <a:solidFill>
+                  <a:srgbClr val="111111"/>
+                </a:solidFill>
+                <a:latin typeface="Times New Roman" pitchFamily="34" charset="0"/>
+                <a:ea typeface="Times New Roman" pitchFamily="34" charset="-122"/>
+                <a:cs typeface="Times New Roman" pitchFamily="34" charset="-120"/>
+              </a:rPr>
+              <a:t>Lines joining places of equal density are called ______.</a:t>
             </a:r>
             <a:endParaRPr lang="en-US" sz="4000" dirty="0"/>
           </a:p>
@@ -20272,7 +19910,7 @@
                 <a:ea typeface="Calibri" pitchFamily="34" charset="-122"/>
                 <a:cs typeface="Calibri" pitchFamily="34" charset="-120"/>
               </a:rPr>
-              <a:t>FORMATIVE EVALUATION</a:t>
+              <a:t>REMEDIATION</a:t>
             </a:r>
             <a:endParaRPr lang="en-US" sz="1400" dirty="0"/>
           </a:p>
@@ -20337,7 +19975,7 @@
                 <a:ea typeface="Times New Roman" pitchFamily="34" charset="-122"/>
                 <a:cs typeface="Times New Roman" pitchFamily="34" charset="-120"/>
               </a:rPr>
-              <a:t>Evaluation 2</a:t>
+              <a:t>Remediation (continued)</a:t>
             </a:r>
             <a:endParaRPr lang="en-US" sz="3600" dirty="0"/>
           </a:p>
@@ -20364,11 +20002,13 @@
           <a:bodyPr wrap="square" lIns="0" tIns="0" rIns="0" bIns="0" rtlCol="0" anchor="t"/>
           <a:lstStyle/>
           <a:p>
-            <a:pPr algn="l" indent="0" marL="0">
+            <a:pPr algn="l" marL="342900" indent="-342900">
               <a:spcAft>
                 <a:spcPts val="800"/>
               </a:spcAft>
-              <a:buNone/>
+              <a:buSzPct val="100000"/>
+              <a:buFont typeface="+mj-lt"/>
+              <a:buAutoNum type="arabicPeriod" startAt="1"/>
             </a:pPr>
             <a:r>
               <a:rPr lang="en-US" sz="4000" dirty="0">
@@ -20379,7 +20019,7 @@
                 <a:ea typeface="Times New Roman" pitchFamily="34" charset="-122"/>
                 <a:cs typeface="Times New Roman" pitchFamily="34" charset="-120"/>
               </a:rPr>
-              <a:t>What does a Lorenz curve far from the diagonal show?</a:t>
+              <a:t>The ______ curve compares cumulative population with cumulative area.</a:t>
             </a:r>
             <a:endParaRPr lang="en-US" sz="4000" dirty="0"/>
           </a:p>
@@ -20491,7 +20131,7 @@
                 <a:ea typeface="Calibri" pitchFamily="34" charset="-122"/>
                 <a:cs typeface="Calibri" pitchFamily="34" charset="-120"/>
               </a:rPr>
-              <a:t>FORMATIVE EVALUATION</a:t>
+              <a:t>HOMEWORK</a:t>
             </a:r>
             <a:endParaRPr lang="en-US" sz="1400" dirty="0"/>
           </a:p>
@@ -20556,7 +20196,7 @@
                 <a:ea typeface="Times New Roman" pitchFamily="34" charset="-122"/>
                 <a:cs typeface="Times New Roman" pitchFamily="34" charset="-120"/>
               </a:rPr>
-              <a:t>Expected Answer</a:t>
+              <a:t>Homework</a:t>
             </a:r>
             <a:endParaRPr lang="en-US" sz="3600" dirty="0"/>
           </a:p>
@@ -20598,7 +20238,7 @@
                 <a:ea typeface="Times New Roman" pitchFamily="34" charset="-122"/>
                 <a:cs typeface="Times New Roman" pitchFamily="34" charset="-120"/>
               </a:rPr>
-              <a:t>A very uneven distribution of the population.</a:t>
+              <a:t>Name two regions of the world that are densely populated.</a:t>
             </a:r>
             <a:endParaRPr lang="en-US" sz="4000" dirty="0"/>
           </a:p>
@@ -20710,7 +20350,7 @@
                 <a:ea typeface="Calibri" pitchFamily="34" charset="-122"/>
                 <a:cs typeface="Calibri" pitchFamily="34" charset="-120"/>
               </a:rPr>
-              <a:t>REMEDIATION</a:t>
+              <a:t>NEXT LESSON</a:t>
             </a:r>
             <a:endParaRPr lang="en-US" sz="1400" dirty="0"/>
           </a:p>
@@ -20775,7 +20415,7 @@
                 <a:ea typeface="Times New Roman" pitchFamily="34" charset="-122"/>
                 <a:cs typeface="Times New Roman" pitchFamily="34" charset="-120"/>
               </a:rPr>
-              <a:t>Remediation</a:t>
+              <a:t>Next Lesson</a:t>
             </a:r>
             <a:endParaRPr lang="en-US" sz="3600" dirty="0"/>
           </a:p>
@@ -20799,10 +20439,10 @@
           <a:ln/>
         </p:spPr>
         <p:txBody>
-          <a:bodyPr wrap="square" lIns="0" tIns="0" rIns="0" bIns="0" rtlCol="0" anchor="t"/>
-          <a:lstStyle/>
-          <a:p>
-            <a:pPr algn="l" indent="0" marL="0">
+          <a:bodyPr wrap="square" lIns="0" tIns="0" rIns="0" bIns="0" rtlCol="0" anchor="ctr"/>
+          <a:lstStyle/>
+          <a:p>
+            <a:pPr algn="ctr" indent="0" marL="0">
               <a:spcAft>
                 <a:spcPts val="800"/>
               </a:spcAft>
@@ -20817,51 +20457,27 @@
                 <a:ea typeface="Times New Roman" pitchFamily="34" charset="-122"/>
                 <a:cs typeface="Times New Roman" pitchFamily="34" charset="-120"/>
               </a:rPr>
-              <a:t>Fill in the blanks:</a:t>
+              <a:t>Our next lesson will be on:</a:t>
             </a:r>
             <a:endParaRPr lang="en-US" sz="4000" dirty="0"/>
           </a:p>
           <a:p>
-            <a:pPr algn="l" marL="342900" indent="-342900">
+            <a:pPr algn="ctr" indent="0" marL="0">
               <a:spcAft>
                 <a:spcPts val="800"/>
               </a:spcAft>
-              <a:buSzPct val="100000"/>
-              <a:buFont typeface="+mj-lt"/>
-              <a:buAutoNum type="arabicPeriod" startAt="1"/>
+              <a:buNone/>
             </a:pPr>
             <a:r>
-              <a:rPr lang="en-US" sz="4000" dirty="0">
-                <a:solidFill>
-                  <a:srgbClr val="111111"/>
+              <a:rPr lang="en-US" sz="4000" b="1" dirty="0">
+                <a:solidFill>
+                  <a:srgbClr val="990011"/>
                 </a:solidFill>
                 <a:latin typeface="Times New Roman" pitchFamily="34" charset="0"/>
                 <a:ea typeface="Times New Roman" pitchFamily="34" charset="-122"/>
                 <a:cs typeface="Times New Roman" pitchFamily="34" charset="-120"/>
               </a:rPr>
-              <a:t>A map with shades of colour for each region is a ______ map.</a:t>
-            </a:r>
-            <a:endParaRPr lang="en-US" sz="4000" dirty="0"/>
-          </a:p>
-          <a:p>
-            <a:pPr algn="l" marL="342900" indent="-342900">
-              <a:spcAft>
-                <a:spcPts val="800"/>
-              </a:spcAft>
-              <a:buSzPct val="100000"/>
-              <a:buFont typeface="+mj-lt"/>
-              <a:buAutoNum type="arabicPeriod" startAt="1"/>
-            </a:pPr>
-            <a:r>
-              <a:rPr lang="en-US" sz="4000" dirty="0">
-                <a:solidFill>
-                  <a:srgbClr val="111111"/>
-                </a:solidFill>
-                <a:latin typeface="Times New Roman" pitchFamily="34" charset="0"/>
-                <a:ea typeface="Times New Roman" pitchFamily="34" charset="-122"/>
-                <a:cs typeface="Times New Roman" pitchFamily="34" charset="-120"/>
-              </a:rPr>
-              <a:t>Lines joining places of equal density are called ______.</a:t>
+              <a:t>Lesson 3: Spatial Population Distribution and its Factors</a:t>
             </a:r>
             <a:endParaRPr lang="en-US" sz="4000" dirty="0"/>
           </a:p>
@@ -20973,1016 +20589,6 @@
                 <a:ea typeface="Calibri" pitchFamily="34" charset="-122"/>
                 <a:cs typeface="Calibri" pitchFamily="34" charset="-120"/>
               </a:rPr>
-              <a:t>REMEDIATION</a:t>
-            </a:r>
-            <a:endParaRPr lang="en-US" sz="1400" dirty="0"/>
-          </a:p>
-        </p:txBody>
-      </p:sp>
-      <p:pic>
-        <p:nvPicPr>
-          <p:cNvPr id="3" name="Image 0" descr="/home/claude/f4/img/minesec_sheet.png">    </p:cNvPr>
-          <p:cNvPicPr>
-            <a:picLocks noChangeAspect="1"/>
-          </p:cNvPicPr>
-          <p:nvPr/>
-        </p:nvPicPr>
-        <p:blipFill>
-          <a:blip r:embed="rId1"/>
-          <a:stretch>
-            <a:fillRect/>
-          </a:stretch>
-        </p:blipFill>
-        <p:spPr>
-          <a:xfrm>
-            <a:off x="0" y="658368"/>
-            <a:ext cx="5120640" cy="5833872"/>
-          </a:xfrm>
-          <a:prstGeom prst="rect">
-            <a:avLst/>
-          </a:prstGeom>
-        </p:spPr>
-      </p:pic>
-      <p:sp>
-        <p:nvSpPr>
-          <p:cNvPr id="4" name="Text 1"/>
-          <p:cNvSpPr/>
-          <p:nvPr/>
-        </p:nvSpPr>
-        <p:spPr>
-          <a:xfrm>
-            <a:off x="5349240" y="1005840"/>
-            <a:ext cx="6522415" cy="731520"/>
-          </a:xfrm>
-          <a:prstGeom prst="rect">
-            <a:avLst/>
-          </a:prstGeom>
-          <a:noFill/>
-          <a:ln/>
-        </p:spPr>
-        <p:txBody>
-          <a:bodyPr wrap="square" lIns="0" tIns="0" rIns="0" bIns="0" rtlCol="0" anchor="ctr">
-            <a:normAutofit/>
-          </a:bodyPr>
-          <a:lstStyle/>
-          <a:p>
-            <a:pPr algn="ctr" indent="0" marL="0">
-              <a:buNone/>
-            </a:pPr>
-            <a:r>
-              <a:rPr lang="en-US" sz="3600" b="1" dirty="0">
-                <a:solidFill>
-                  <a:srgbClr val="990011"/>
-                </a:solidFill>
-                <a:latin typeface="Times New Roman" pitchFamily="34" charset="0"/>
-                <a:ea typeface="Times New Roman" pitchFamily="34" charset="-122"/>
-                <a:cs typeface="Times New Roman" pitchFamily="34" charset="-120"/>
-              </a:rPr>
-              <a:t>Remediation (continued)</a:t>
-            </a:r>
-            <a:endParaRPr lang="en-US" sz="3600" dirty="0"/>
-          </a:p>
-        </p:txBody>
-      </p:sp>
-      <p:sp>
-        <p:nvSpPr>
-          <p:cNvPr id="5" name="Text 2"/>
-          <p:cNvSpPr/>
-          <p:nvPr/>
-        </p:nvSpPr>
-        <p:spPr>
-          <a:xfrm>
-            <a:off x="5349240" y="1783080"/>
-            <a:ext cx="6522415" cy="4663440"/>
-          </a:xfrm>
-          <a:prstGeom prst="rect">
-            <a:avLst/>
-          </a:prstGeom>
-          <a:noFill/>
-          <a:ln/>
-        </p:spPr>
-        <p:txBody>
-          <a:bodyPr wrap="square" lIns="0" tIns="0" rIns="0" bIns="0" rtlCol="0" anchor="t"/>
-          <a:lstStyle/>
-          <a:p>
-            <a:pPr algn="l" marL="342900" indent="-342900">
-              <a:spcAft>
-                <a:spcPts val="800"/>
-              </a:spcAft>
-              <a:buSzPct val="100000"/>
-              <a:buFont typeface="+mj-lt"/>
-              <a:buAutoNum type="arabicPeriod" startAt="1"/>
-            </a:pPr>
-            <a:r>
-              <a:rPr lang="en-US" sz="4000" dirty="0">
-                <a:solidFill>
-                  <a:srgbClr val="111111"/>
-                </a:solidFill>
-                <a:latin typeface="Times New Roman" pitchFamily="34" charset="0"/>
-                <a:ea typeface="Times New Roman" pitchFamily="34" charset="-122"/>
-                <a:cs typeface="Times New Roman" pitchFamily="34" charset="-120"/>
-              </a:rPr>
-              <a:t>The ______ curve compares cumulative population with cumulative area.</a:t>
-            </a:r>
-            <a:endParaRPr lang="en-US" sz="4000" dirty="0"/>
-          </a:p>
-        </p:txBody>
-      </p:sp>
-      <p:sp>
-        <p:nvSpPr>
-          <p:cNvPr id="25" name="Slide Number Placeholder 0"/>
-          <p:cNvSpPr>
-            <a:spLocks noGrp="1"/>
-          </p:cNvSpPr>
-          <p:nvPr>
-            <p:ph type="sldNum" sz="quarter" idx="4294967295"/>
-          </p:nvPr>
-        </p:nvSpPr>
-        <p:spPr>
-          <a:xfrm>
-            <a:off x="27432" y="91440"/>
-            <a:ext cx="585216" cy="475488"/>
-          </a:xfrm>
-          <a:prstGeom prst="rect">
-            <a:avLst/>
-          </a:prstGeom>
-          <a:extLst>
-            <a:ext uri="{C572A759-6A51-4108-AA02-DFA0A04FC94B}">
-              <ma14:wrappingTextBoxFlag xmlns:ma14="http://schemas.microsoft.com/office/mac/drawingml/2011/main" val="0"/>
-            </a:ext>
-          </a:extLst>
-        </p:spPr>
-        <p:txBody>
-          <a:bodyPr/>
-          <a:lstStyle>
-            <a:lvl1pPr>
-              <a:defRPr sz="2000">
-                <a:solidFill>
-                  <a:srgbClr val="FFFFFF"/>
-                </a:solidFill>
-                <a:latin typeface="Calibri"/>
-                <a:ea typeface="Calibri"/>
-                <a:cs typeface="Calibri"/>
-              </a:defRPr>
-            </a:lvl1pPr>
-          </a:lstStyle>
-          <a:p>
-            <a:pPr algn="ctr"/>
-            <a:fld id="{F7021451-1387-4CA6-816F-3879F97B5CBC}" type="slidenum">
-              <a:rPr b="1" lang="en-US"/>
-              <a:t>58</a:t>
-            </a:fld>
-            <a:endParaRPr lang="en-US"/>
-          </a:p>
-        </p:txBody>
-      </p:sp>
-    </p:spTree>
-  </p:cSld>
-  <p:clrMapOvr>
-    <a:masterClrMapping/>
-  </p:clrMapOvr>
-</p:sld>
-</file>
-
-<file path=ppt/slides/slide59.xml><?xml version="1.0" encoding="utf-8"?>
-<p:sld xmlns:a="http://schemas.openxmlformats.org/drawingml/2006/main" xmlns:r="http://schemas.openxmlformats.org/officeDocument/2006/relationships" xmlns:p="http://schemas.openxmlformats.org/presentationml/2006/main">
-  <p:cSld name="Slide 59">
-    <p:spTree>
-      <p:nvGrpSpPr>
-        <p:cNvPr id="1" name=""/>
-        <p:cNvGrpSpPr/>
-        <p:nvPr/>
-      </p:nvGrpSpPr>
-      <p:grpSpPr>
-        <a:xfrm>
-          <a:off x="0" y="0"/>
-          <a:ext cx="0" cy="0"/>
-          <a:chOff x="0" y="0"/>
-          <a:chExt cx="0" cy="0"/>
-        </a:xfrm>
-      </p:grpSpPr>
-      <p:sp>
-        <p:nvSpPr>
-          <p:cNvPr id="2" name="Text 0"/>
-          <p:cNvSpPr/>
-          <p:nvPr/>
-        </p:nvSpPr>
-        <p:spPr>
-          <a:xfrm>
-            <a:off x="457200" y="713232"/>
-            <a:ext cx="11368735" cy="274320"/>
-          </a:xfrm>
-          <a:prstGeom prst="rect">
-            <a:avLst/>
-          </a:prstGeom>
-          <a:noFill/>
-          <a:ln/>
-        </p:spPr>
-        <p:txBody>
-          <a:bodyPr wrap="square" lIns="0" tIns="0" rIns="0" bIns="0" rtlCol="0" anchor="ctr"/>
-          <a:lstStyle/>
-          <a:p>
-            <a:pPr algn="r" indent="0" marL="0">
-              <a:buNone/>
-            </a:pPr>
-            <a:r>
-              <a:rPr lang="en-US" sz="1400" b="1" dirty="0">
-                <a:solidFill>
-                  <a:srgbClr val="1C3F6E"/>
-                </a:solidFill>
-                <a:latin typeface="Calibri" pitchFamily="34" charset="0"/>
-                <a:ea typeface="Calibri" pitchFamily="34" charset="-122"/>
-                <a:cs typeface="Calibri" pitchFamily="34" charset="-120"/>
-              </a:rPr>
-              <a:t>HOMEWORK</a:t>
-            </a:r>
-            <a:endParaRPr lang="en-US" sz="1400" dirty="0"/>
-          </a:p>
-        </p:txBody>
-      </p:sp>
-      <p:pic>
-        <p:nvPicPr>
-          <p:cNvPr id="3" name="Image 0" descr="/home/claude/f4/img/minesec_sheet.png">    </p:cNvPr>
-          <p:cNvPicPr>
-            <a:picLocks noChangeAspect="1"/>
-          </p:cNvPicPr>
-          <p:nvPr/>
-        </p:nvPicPr>
-        <p:blipFill>
-          <a:blip r:embed="rId1"/>
-          <a:stretch>
-            <a:fillRect/>
-          </a:stretch>
-        </p:blipFill>
-        <p:spPr>
-          <a:xfrm>
-            <a:off x="0" y="658368"/>
-            <a:ext cx="5120640" cy="5833872"/>
-          </a:xfrm>
-          <a:prstGeom prst="rect">
-            <a:avLst/>
-          </a:prstGeom>
-        </p:spPr>
-      </p:pic>
-      <p:sp>
-        <p:nvSpPr>
-          <p:cNvPr id="4" name="Text 1"/>
-          <p:cNvSpPr/>
-          <p:nvPr/>
-        </p:nvSpPr>
-        <p:spPr>
-          <a:xfrm>
-            <a:off x="5349240" y="1005840"/>
-            <a:ext cx="6522415" cy="731520"/>
-          </a:xfrm>
-          <a:prstGeom prst="rect">
-            <a:avLst/>
-          </a:prstGeom>
-          <a:noFill/>
-          <a:ln/>
-        </p:spPr>
-        <p:txBody>
-          <a:bodyPr wrap="square" lIns="0" tIns="0" rIns="0" bIns="0" rtlCol="0" anchor="ctr">
-            <a:normAutofit/>
-          </a:bodyPr>
-          <a:lstStyle/>
-          <a:p>
-            <a:pPr algn="ctr" indent="0" marL="0">
-              <a:buNone/>
-            </a:pPr>
-            <a:r>
-              <a:rPr lang="en-US" sz="3600" b="1" dirty="0">
-                <a:solidFill>
-                  <a:srgbClr val="990011"/>
-                </a:solidFill>
-                <a:latin typeface="Times New Roman" pitchFamily="34" charset="0"/>
-                <a:ea typeface="Times New Roman" pitchFamily="34" charset="-122"/>
-                <a:cs typeface="Times New Roman" pitchFamily="34" charset="-120"/>
-              </a:rPr>
-              <a:t>Homework</a:t>
-            </a:r>
-            <a:endParaRPr lang="en-US" sz="3600" dirty="0"/>
-          </a:p>
-        </p:txBody>
-      </p:sp>
-      <p:sp>
-        <p:nvSpPr>
-          <p:cNvPr id="5" name="Text 2"/>
-          <p:cNvSpPr/>
-          <p:nvPr/>
-        </p:nvSpPr>
-        <p:spPr>
-          <a:xfrm>
-            <a:off x="5349240" y="1783080"/>
-            <a:ext cx="6522415" cy="4663440"/>
-          </a:xfrm>
-          <a:prstGeom prst="rect">
-            <a:avLst/>
-          </a:prstGeom>
-          <a:noFill/>
-          <a:ln/>
-        </p:spPr>
-        <p:txBody>
-          <a:bodyPr wrap="square" lIns="0" tIns="0" rIns="0" bIns="0" rtlCol="0" anchor="t"/>
-          <a:lstStyle/>
-          <a:p>
-            <a:pPr algn="l" indent="0" marL="0">
-              <a:spcAft>
-                <a:spcPts val="800"/>
-              </a:spcAft>
-              <a:buNone/>
-            </a:pPr>
-            <a:r>
-              <a:rPr lang="en-US" sz="4000" dirty="0">
-                <a:solidFill>
-                  <a:srgbClr val="111111"/>
-                </a:solidFill>
-                <a:latin typeface="Times New Roman" pitchFamily="34" charset="0"/>
-                <a:ea typeface="Times New Roman" pitchFamily="34" charset="-122"/>
-                <a:cs typeface="Times New Roman" pitchFamily="34" charset="-120"/>
-              </a:rPr>
-              <a:t>Name two regions of the world that are densely populated.</a:t>
-            </a:r>
-            <a:endParaRPr lang="en-US" sz="4000" dirty="0"/>
-          </a:p>
-        </p:txBody>
-      </p:sp>
-      <p:sp>
-        <p:nvSpPr>
-          <p:cNvPr id="25" name="Slide Number Placeholder 0"/>
-          <p:cNvSpPr>
-            <a:spLocks noGrp="1"/>
-          </p:cNvSpPr>
-          <p:nvPr>
-            <p:ph type="sldNum" sz="quarter" idx="4294967295"/>
-          </p:nvPr>
-        </p:nvSpPr>
-        <p:spPr>
-          <a:xfrm>
-            <a:off x="27432" y="91440"/>
-            <a:ext cx="585216" cy="475488"/>
-          </a:xfrm>
-          <a:prstGeom prst="rect">
-            <a:avLst/>
-          </a:prstGeom>
-          <a:extLst>
-            <a:ext uri="{C572A759-6A51-4108-AA02-DFA0A04FC94B}">
-              <ma14:wrappingTextBoxFlag xmlns:ma14="http://schemas.microsoft.com/office/mac/drawingml/2011/main" val="0"/>
-            </a:ext>
-          </a:extLst>
-        </p:spPr>
-        <p:txBody>
-          <a:bodyPr/>
-          <a:lstStyle>
-            <a:lvl1pPr>
-              <a:defRPr sz="2000">
-                <a:solidFill>
-                  <a:srgbClr val="FFFFFF"/>
-                </a:solidFill>
-                <a:latin typeface="Calibri"/>
-                <a:ea typeface="Calibri"/>
-                <a:cs typeface="Calibri"/>
-              </a:defRPr>
-            </a:lvl1pPr>
-          </a:lstStyle>
-          <a:p>
-            <a:pPr algn="ctr"/>
-            <a:fld id="{F7021451-1387-4CA6-816F-3879F97B5CBC}" type="slidenum">
-              <a:rPr b="1" lang="en-US"/>
-              <a:t>59</a:t>
-            </a:fld>
-            <a:endParaRPr lang="en-US"/>
-          </a:p>
-        </p:txBody>
-      </p:sp>
-    </p:spTree>
-  </p:cSld>
-  <p:clrMapOvr>
-    <a:masterClrMapping/>
-  </p:clrMapOvr>
-</p:sld>
-</file>
-
-<file path=ppt/slides/slide6.xml><?xml version="1.0" encoding="utf-8"?>
-<p:sld xmlns:a="http://schemas.openxmlformats.org/drawingml/2006/main" xmlns:r="http://schemas.openxmlformats.org/officeDocument/2006/relationships" xmlns:p="http://schemas.openxmlformats.org/presentationml/2006/main">
-  <p:cSld name="Slide 6">
-    <p:spTree>
-      <p:nvGrpSpPr>
-        <p:cNvPr id="1" name=""/>
-        <p:cNvGrpSpPr/>
-        <p:nvPr/>
-      </p:nvGrpSpPr>
-      <p:grpSpPr>
-        <a:xfrm>
-          <a:off x="0" y="0"/>
-          <a:ext cx="0" cy="0"/>
-          <a:chOff x="0" y="0"/>
-          <a:chExt cx="0" cy="0"/>
-        </a:xfrm>
-      </p:grpSpPr>
-      <p:sp>
-        <p:nvSpPr>
-          <p:cNvPr id="2" name="Text 0"/>
-          <p:cNvSpPr/>
-          <p:nvPr/>
-        </p:nvSpPr>
-        <p:spPr>
-          <a:xfrm>
-            <a:off x="457200" y="713232"/>
-            <a:ext cx="11368735" cy="274320"/>
-          </a:xfrm>
-          <a:prstGeom prst="rect">
-            <a:avLst/>
-          </a:prstGeom>
-          <a:noFill/>
-          <a:ln/>
-        </p:spPr>
-        <p:txBody>
-          <a:bodyPr wrap="square" lIns="0" tIns="0" rIns="0" bIns="0" rtlCol="0" anchor="ctr"/>
-          <a:lstStyle/>
-          <a:p>
-            <a:pPr algn="r" indent="0" marL="0">
-              <a:buNone/>
-            </a:pPr>
-            <a:r>
-              <a:rPr lang="en-US" sz="1400" b="1" dirty="0">
-                <a:solidFill>
-                  <a:srgbClr val="1C3F6E"/>
-                </a:solidFill>
-                <a:latin typeface="Calibri" pitchFamily="34" charset="0"/>
-                <a:ea typeface="Calibri" pitchFamily="34" charset="-122"/>
-                <a:cs typeface="Calibri" pitchFamily="34" charset="-120"/>
-              </a:rPr>
-              <a:t>LESSON PLAN</a:t>
-            </a:r>
-            <a:endParaRPr lang="en-US" sz="1400" dirty="0"/>
-          </a:p>
-        </p:txBody>
-      </p:sp>
-      <p:pic>
-        <p:nvPicPr>
-          <p:cNvPr id="3" name="Image 0" descr="/home/claude/f4/img/minesec_sheet.png">    </p:cNvPr>
-          <p:cNvPicPr>
-            <a:picLocks noChangeAspect="1"/>
-          </p:cNvPicPr>
-          <p:nvPr/>
-        </p:nvPicPr>
-        <p:blipFill>
-          <a:blip r:embed="rId1"/>
-          <a:stretch>
-            <a:fillRect/>
-          </a:stretch>
-        </p:blipFill>
-        <p:spPr>
-          <a:xfrm>
-            <a:off x="0" y="658368"/>
-            <a:ext cx="2468880" cy="5833872"/>
-          </a:xfrm>
-          <a:prstGeom prst="rect">
-            <a:avLst/>
-          </a:prstGeom>
-        </p:spPr>
-      </p:pic>
-      <p:sp>
-        <p:nvSpPr>
-          <p:cNvPr id="4" name="Text 1"/>
-          <p:cNvSpPr/>
-          <p:nvPr/>
-        </p:nvSpPr>
-        <p:spPr>
-          <a:xfrm>
-            <a:off x="2697480" y="1005840"/>
-            <a:ext cx="9174175" cy="731520"/>
-          </a:xfrm>
-          <a:prstGeom prst="rect">
-            <a:avLst/>
-          </a:prstGeom>
-          <a:noFill/>
-          <a:ln/>
-        </p:spPr>
-        <p:txBody>
-          <a:bodyPr wrap="square" lIns="0" tIns="0" rIns="0" bIns="0" rtlCol="0" anchor="ctr">
-            <a:normAutofit/>
-          </a:bodyPr>
-          <a:lstStyle/>
-          <a:p>
-            <a:pPr algn="ctr" indent="0" marL="0">
-              <a:buNone/>
-            </a:pPr>
-            <a:r>
-              <a:rPr lang="en-US" sz="3600" b="1" dirty="0">
-                <a:solidFill>
-                  <a:srgbClr val="990011"/>
-                </a:solidFill>
-                <a:latin typeface="Times New Roman" pitchFamily="34" charset="0"/>
-                <a:ea typeface="Times New Roman" pitchFamily="34" charset="-122"/>
-                <a:cs typeface="Times New Roman" pitchFamily="34" charset="-120"/>
-              </a:rPr>
-              <a:t>Lesson Plan</a:t>
-            </a:r>
-            <a:endParaRPr lang="en-US" sz="3600" dirty="0"/>
-          </a:p>
-        </p:txBody>
-      </p:sp>
-      <p:sp>
-        <p:nvSpPr>
-          <p:cNvPr id="5" name="Text 2"/>
-          <p:cNvSpPr/>
-          <p:nvPr/>
-        </p:nvSpPr>
-        <p:spPr>
-          <a:xfrm>
-            <a:off x="2697480" y="1783080"/>
-            <a:ext cx="9174175" cy="4663440"/>
-          </a:xfrm>
-          <a:prstGeom prst="rect">
-            <a:avLst/>
-          </a:prstGeom>
-          <a:noFill/>
-          <a:ln/>
-        </p:spPr>
-        <p:txBody>
-          <a:bodyPr wrap="square" lIns="0" tIns="0" rIns="0" bIns="0" rtlCol="0" anchor="t"/>
-          <a:lstStyle/>
-          <a:p>
-            <a:pPr algn="l" marL="342900" indent="-342900">
-              <a:spcAft>
-                <a:spcPts val="800"/>
-              </a:spcAft>
-              <a:buSzPct val="100000"/>
-              <a:buFont typeface="+mj-lt"/>
-              <a:buAutoNum type="arabicPeriod" startAt="1"/>
-            </a:pPr>
-            <a:r>
-              <a:rPr lang="en-US" sz="4000" dirty="0">
-                <a:solidFill>
-                  <a:srgbClr val="111111"/>
-                </a:solidFill>
-                <a:latin typeface="Times New Roman" pitchFamily="34" charset="0"/>
-                <a:ea typeface="Times New Roman" pitchFamily="34" charset="-122"/>
-                <a:cs typeface="Times New Roman" pitchFamily="34" charset="-120"/>
-              </a:rPr>
-              <a:t>Correction of the homework</a:t>
-            </a:r>
-            <a:endParaRPr lang="en-US" sz="4000" dirty="0"/>
-          </a:p>
-          <a:p>
-            <a:pPr algn="l" marL="342900" indent="-342900">
-              <a:spcAft>
-                <a:spcPts val="800"/>
-              </a:spcAft>
-              <a:buSzPct val="100000"/>
-              <a:buFont typeface="+mj-lt"/>
-              <a:buAutoNum type="arabicPeriod" startAt="1"/>
-            </a:pPr>
-            <a:r>
-              <a:rPr lang="en-US" sz="4000" dirty="0">
-                <a:solidFill>
-                  <a:srgbClr val="111111"/>
-                </a:solidFill>
-                <a:latin typeface="Times New Roman" pitchFamily="34" charset="0"/>
-                <a:ea typeface="Times New Roman" pitchFamily="34" charset="-122"/>
-                <a:cs typeface="Times New Roman" pitchFamily="34" charset="-120"/>
-              </a:rPr>
-              <a:t>Objectives and recall</a:t>
-            </a:r>
-            <a:endParaRPr lang="en-US" sz="4000" dirty="0"/>
-          </a:p>
-          <a:p>
-            <a:pPr algn="l" marL="342900" indent="-342900">
-              <a:spcAft>
-                <a:spcPts val="800"/>
-              </a:spcAft>
-              <a:buSzPct val="100000"/>
-              <a:buFont typeface="+mj-lt"/>
-              <a:buAutoNum type="arabicPeriod" startAt="1"/>
-            </a:pPr>
-            <a:r>
-              <a:rPr lang="en-US" sz="4000" dirty="0">
-                <a:solidFill>
-                  <a:srgbClr val="111111"/>
-                </a:solidFill>
-                <a:latin typeface="Times New Roman" pitchFamily="34" charset="0"/>
-                <a:ea typeface="Times New Roman" pitchFamily="34" charset="-122"/>
-                <a:cs typeface="Times New Roman" pitchFamily="34" charset="-120"/>
-              </a:rPr>
-              <a:t>Real-life situation and action to take</a:t>
-            </a:r>
-            <a:endParaRPr lang="en-US" sz="4000" dirty="0"/>
-          </a:p>
-          <a:p>
-            <a:pPr algn="l" marL="342900" indent="-342900">
-              <a:spcAft>
-                <a:spcPts val="800"/>
-              </a:spcAft>
-              <a:buSzPct val="100000"/>
-              <a:buFont typeface="+mj-lt"/>
-              <a:buAutoNum type="arabicPeriod" startAt="1"/>
-            </a:pPr>
-            <a:r>
-              <a:rPr lang="en-US" sz="4000" dirty="0">
-                <a:solidFill>
-                  <a:srgbClr val="111111"/>
-                </a:solidFill>
-                <a:latin typeface="Times New Roman" pitchFamily="34" charset="0"/>
-                <a:ea typeface="Times New Roman" pitchFamily="34" charset="-122"/>
-                <a:cs typeface="Times New Roman" pitchFamily="34" charset="-120"/>
-              </a:rPr>
-              <a:t>Learning activities</a:t>
-            </a:r>
-            <a:endParaRPr lang="en-US" sz="4000" dirty="0"/>
-          </a:p>
-          <a:p>
-            <a:pPr algn="l" marL="342900" indent="-342900">
-              <a:spcAft>
-                <a:spcPts val="800"/>
-              </a:spcAft>
-              <a:buSzPct val="100000"/>
-              <a:buFont typeface="+mj-lt"/>
-              <a:buAutoNum type="arabicPeriod" startAt="1"/>
-            </a:pPr>
-            <a:r>
-              <a:rPr lang="en-US" sz="4000" dirty="0">
-                <a:solidFill>
-                  <a:srgbClr val="111111"/>
-                </a:solidFill>
-                <a:latin typeface="Times New Roman" pitchFamily="34" charset="0"/>
-                <a:ea typeface="Times New Roman" pitchFamily="34" charset="-122"/>
-                <a:cs typeface="Times New Roman" pitchFamily="34" charset="-120"/>
-              </a:rPr>
-              <a:t>Board summary</a:t>
-            </a:r>
-            <a:endParaRPr lang="en-US" sz="4000" dirty="0"/>
-          </a:p>
-          <a:p>
-            <a:pPr algn="l" marL="342900" indent="-342900">
-              <a:spcAft>
-                <a:spcPts val="800"/>
-              </a:spcAft>
-              <a:buSzPct val="100000"/>
-              <a:buFont typeface="+mj-lt"/>
-              <a:buAutoNum type="arabicPeriod" startAt="1"/>
-            </a:pPr>
-            <a:r>
-              <a:rPr lang="en-US" sz="4000" dirty="0">
-                <a:solidFill>
-                  <a:srgbClr val="111111"/>
-                </a:solidFill>
-                <a:latin typeface="Times New Roman" pitchFamily="34" charset="0"/>
-                <a:ea typeface="Times New Roman" pitchFamily="34" charset="-122"/>
-                <a:cs typeface="Times New Roman" pitchFamily="34" charset="-120"/>
-              </a:rPr>
-              <a:t>Evaluation, remediation and homework</a:t>
-            </a:r>
-            <a:endParaRPr lang="en-US" sz="4000" dirty="0"/>
-          </a:p>
-        </p:txBody>
-      </p:sp>
-      <p:sp>
-        <p:nvSpPr>
-          <p:cNvPr id="25" name="Slide Number Placeholder 0"/>
-          <p:cNvSpPr>
-            <a:spLocks noGrp="1"/>
-          </p:cNvSpPr>
-          <p:nvPr>
-            <p:ph type="sldNum" sz="quarter" idx="4294967295"/>
-          </p:nvPr>
-        </p:nvSpPr>
-        <p:spPr>
-          <a:xfrm>
-            <a:off x="27432" y="91440"/>
-            <a:ext cx="585216" cy="475488"/>
-          </a:xfrm>
-          <a:prstGeom prst="rect">
-            <a:avLst/>
-          </a:prstGeom>
-          <a:extLst>
-            <a:ext uri="{C572A759-6A51-4108-AA02-DFA0A04FC94B}">
-              <ma14:wrappingTextBoxFlag xmlns:ma14="http://schemas.microsoft.com/office/mac/drawingml/2011/main" val="0"/>
-            </a:ext>
-          </a:extLst>
-        </p:spPr>
-        <p:txBody>
-          <a:bodyPr/>
-          <a:lstStyle>
-            <a:lvl1pPr>
-              <a:defRPr sz="2000">
-                <a:solidFill>
-                  <a:srgbClr val="FFFFFF"/>
-                </a:solidFill>
-                <a:latin typeface="Calibri"/>
-                <a:ea typeface="Calibri"/>
-                <a:cs typeface="Calibri"/>
-              </a:defRPr>
-            </a:lvl1pPr>
-          </a:lstStyle>
-          <a:p>
-            <a:pPr algn="ctr"/>
-            <a:fld id="{F7021451-1387-4CA6-816F-3879F97B5CBC}" type="slidenum">
-              <a:rPr b="1" lang="en-US"/>
-              <a:t>6</a:t>
-            </a:fld>
-            <a:endParaRPr lang="en-US"/>
-          </a:p>
-        </p:txBody>
-      </p:sp>
-    </p:spTree>
-  </p:cSld>
-  <p:clrMapOvr>
-    <a:masterClrMapping/>
-  </p:clrMapOvr>
-</p:sld>
-</file>
-
-<file path=ppt/slides/slide60.xml><?xml version="1.0" encoding="utf-8"?>
-<p:sld xmlns:a="http://schemas.openxmlformats.org/drawingml/2006/main" xmlns:r="http://schemas.openxmlformats.org/officeDocument/2006/relationships" xmlns:p="http://schemas.openxmlformats.org/presentationml/2006/main">
-  <p:cSld name="Slide 60">
-    <p:spTree>
-      <p:nvGrpSpPr>
-        <p:cNvPr id="1" name=""/>
-        <p:cNvGrpSpPr/>
-        <p:nvPr/>
-      </p:nvGrpSpPr>
-      <p:grpSpPr>
-        <a:xfrm>
-          <a:off x="0" y="0"/>
-          <a:ext cx="0" cy="0"/>
-          <a:chOff x="0" y="0"/>
-          <a:chExt cx="0" cy="0"/>
-        </a:xfrm>
-      </p:grpSpPr>
-      <p:sp>
-        <p:nvSpPr>
-          <p:cNvPr id="2" name="Text 0"/>
-          <p:cNvSpPr/>
-          <p:nvPr/>
-        </p:nvSpPr>
-        <p:spPr>
-          <a:xfrm>
-            <a:off x="457200" y="713232"/>
-            <a:ext cx="11368735" cy="274320"/>
-          </a:xfrm>
-          <a:prstGeom prst="rect">
-            <a:avLst/>
-          </a:prstGeom>
-          <a:noFill/>
-          <a:ln/>
-        </p:spPr>
-        <p:txBody>
-          <a:bodyPr wrap="square" lIns="0" tIns="0" rIns="0" bIns="0" rtlCol="0" anchor="ctr"/>
-          <a:lstStyle/>
-          <a:p>
-            <a:pPr algn="r" indent="0" marL="0">
-              <a:buNone/>
-            </a:pPr>
-            <a:r>
-              <a:rPr lang="en-US" sz="1400" b="1" dirty="0">
-                <a:solidFill>
-                  <a:srgbClr val="1C3F6E"/>
-                </a:solidFill>
-                <a:latin typeface="Calibri" pitchFamily="34" charset="0"/>
-                <a:ea typeface="Calibri" pitchFamily="34" charset="-122"/>
-                <a:cs typeface="Calibri" pitchFamily="34" charset="-120"/>
-              </a:rPr>
-              <a:t>NEXT LESSON</a:t>
-            </a:r>
-            <a:endParaRPr lang="en-US" sz="1400" dirty="0"/>
-          </a:p>
-        </p:txBody>
-      </p:sp>
-      <p:pic>
-        <p:nvPicPr>
-          <p:cNvPr id="3" name="Image 0" descr="/home/claude/f4/img/minesec_sheet.png">    </p:cNvPr>
-          <p:cNvPicPr>
-            <a:picLocks noChangeAspect="1"/>
-          </p:cNvPicPr>
-          <p:nvPr/>
-        </p:nvPicPr>
-        <p:blipFill>
-          <a:blip r:embed="rId1"/>
-          <a:stretch>
-            <a:fillRect/>
-          </a:stretch>
-        </p:blipFill>
-        <p:spPr>
-          <a:xfrm>
-            <a:off x="0" y="658368"/>
-            <a:ext cx="5120640" cy="5833872"/>
-          </a:xfrm>
-          <a:prstGeom prst="rect">
-            <a:avLst/>
-          </a:prstGeom>
-        </p:spPr>
-      </p:pic>
-      <p:sp>
-        <p:nvSpPr>
-          <p:cNvPr id="4" name="Text 1"/>
-          <p:cNvSpPr/>
-          <p:nvPr/>
-        </p:nvSpPr>
-        <p:spPr>
-          <a:xfrm>
-            <a:off x="5349240" y="1005840"/>
-            <a:ext cx="6522415" cy="731520"/>
-          </a:xfrm>
-          <a:prstGeom prst="rect">
-            <a:avLst/>
-          </a:prstGeom>
-          <a:noFill/>
-          <a:ln/>
-        </p:spPr>
-        <p:txBody>
-          <a:bodyPr wrap="square" lIns="0" tIns="0" rIns="0" bIns="0" rtlCol="0" anchor="ctr">
-            <a:normAutofit/>
-          </a:bodyPr>
-          <a:lstStyle/>
-          <a:p>
-            <a:pPr algn="ctr" indent="0" marL="0">
-              <a:buNone/>
-            </a:pPr>
-            <a:r>
-              <a:rPr lang="en-US" sz="3600" b="1" dirty="0">
-                <a:solidFill>
-                  <a:srgbClr val="990011"/>
-                </a:solidFill>
-                <a:latin typeface="Times New Roman" pitchFamily="34" charset="0"/>
-                <a:ea typeface="Times New Roman" pitchFamily="34" charset="-122"/>
-                <a:cs typeface="Times New Roman" pitchFamily="34" charset="-120"/>
-              </a:rPr>
-              <a:t>Next Lesson</a:t>
-            </a:r>
-            <a:endParaRPr lang="en-US" sz="3600" dirty="0"/>
-          </a:p>
-        </p:txBody>
-      </p:sp>
-      <p:sp>
-        <p:nvSpPr>
-          <p:cNvPr id="5" name="Text 2"/>
-          <p:cNvSpPr/>
-          <p:nvPr/>
-        </p:nvSpPr>
-        <p:spPr>
-          <a:xfrm>
-            <a:off x="5349240" y="1783080"/>
-            <a:ext cx="6522415" cy="4663440"/>
-          </a:xfrm>
-          <a:prstGeom prst="rect">
-            <a:avLst/>
-          </a:prstGeom>
-          <a:noFill/>
-          <a:ln/>
-        </p:spPr>
-        <p:txBody>
-          <a:bodyPr wrap="square" lIns="0" tIns="0" rIns="0" bIns="0" rtlCol="0" anchor="ctr"/>
-          <a:lstStyle/>
-          <a:p>
-            <a:pPr algn="ctr" indent="0" marL="0">
-              <a:spcAft>
-                <a:spcPts val="800"/>
-              </a:spcAft>
-              <a:buNone/>
-            </a:pPr>
-            <a:r>
-              <a:rPr lang="en-US" sz="4000" b="1" dirty="0">
-                <a:solidFill>
-                  <a:srgbClr val="111111"/>
-                </a:solidFill>
-                <a:latin typeface="Times New Roman" pitchFamily="34" charset="0"/>
-                <a:ea typeface="Times New Roman" pitchFamily="34" charset="-122"/>
-                <a:cs typeface="Times New Roman" pitchFamily="34" charset="-120"/>
-              </a:rPr>
-              <a:t>Our next lesson will be on:</a:t>
-            </a:r>
-            <a:endParaRPr lang="en-US" sz="4000" dirty="0"/>
-          </a:p>
-          <a:p>
-            <a:pPr algn="ctr" indent="0" marL="0">
-              <a:spcAft>
-                <a:spcPts val="800"/>
-              </a:spcAft>
-              <a:buNone/>
-            </a:pPr>
-            <a:r>
-              <a:rPr lang="en-US" sz="4000" b="1" dirty="0">
-                <a:solidFill>
-                  <a:srgbClr val="990011"/>
-                </a:solidFill>
-                <a:latin typeface="Times New Roman" pitchFamily="34" charset="0"/>
-                <a:ea typeface="Times New Roman" pitchFamily="34" charset="-122"/>
-                <a:cs typeface="Times New Roman" pitchFamily="34" charset="-120"/>
-              </a:rPr>
-              <a:t>Lesson 3: Spatial Population Distribution and its Factors</a:t>
-            </a:r>
-            <a:endParaRPr lang="en-US" sz="4000" dirty="0"/>
-          </a:p>
-        </p:txBody>
-      </p:sp>
-      <p:sp>
-        <p:nvSpPr>
-          <p:cNvPr id="25" name="Slide Number Placeholder 0"/>
-          <p:cNvSpPr>
-            <a:spLocks noGrp="1"/>
-          </p:cNvSpPr>
-          <p:nvPr>
-            <p:ph type="sldNum" sz="quarter" idx="4294967295"/>
-          </p:nvPr>
-        </p:nvSpPr>
-        <p:spPr>
-          <a:xfrm>
-            <a:off x="27432" y="91440"/>
-            <a:ext cx="585216" cy="475488"/>
-          </a:xfrm>
-          <a:prstGeom prst="rect">
-            <a:avLst/>
-          </a:prstGeom>
-          <a:extLst>
-            <a:ext uri="{C572A759-6A51-4108-AA02-DFA0A04FC94B}">
-              <ma14:wrappingTextBoxFlag xmlns:ma14="http://schemas.microsoft.com/office/mac/drawingml/2011/main" val="0"/>
-            </a:ext>
-          </a:extLst>
-        </p:spPr>
-        <p:txBody>
-          <a:bodyPr/>
-          <a:lstStyle>
-            <a:lvl1pPr>
-              <a:defRPr sz="2000">
-                <a:solidFill>
-                  <a:srgbClr val="FFFFFF"/>
-                </a:solidFill>
-                <a:latin typeface="Calibri"/>
-                <a:ea typeface="Calibri"/>
-                <a:cs typeface="Calibri"/>
-              </a:defRPr>
-            </a:lvl1pPr>
-          </a:lstStyle>
-          <a:p>
-            <a:pPr algn="ctr"/>
-            <a:fld id="{F7021451-1387-4CA6-816F-3879F97B5CBC}" type="slidenum">
-              <a:rPr b="1" lang="en-US"/>
-              <a:t>60</a:t>
-            </a:fld>
-            <a:endParaRPr lang="en-US"/>
-          </a:p>
-        </p:txBody>
-      </p:sp>
-    </p:spTree>
-  </p:cSld>
-  <p:clrMapOvr>
-    <a:masterClrMapping/>
-  </p:clrMapOvr>
-</p:sld>
-</file>
-
-<file path=ppt/slides/slide61.xml><?xml version="1.0" encoding="utf-8"?>
-<p:sld xmlns:a="http://schemas.openxmlformats.org/drawingml/2006/main" xmlns:r="http://schemas.openxmlformats.org/officeDocument/2006/relationships" xmlns:p="http://schemas.openxmlformats.org/presentationml/2006/main">
-  <p:cSld name="Slide 61">
-    <p:spTree>
-      <p:nvGrpSpPr>
-        <p:cNvPr id="1" name=""/>
-        <p:cNvGrpSpPr/>
-        <p:nvPr/>
-      </p:nvGrpSpPr>
-      <p:grpSpPr>
-        <a:xfrm>
-          <a:off x="0" y="0"/>
-          <a:ext cx="0" cy="0"/>
-          <a:chOff x="0" y="0"/>
-          <a:chExt cx="0" cy="0"/>
-        </a:xfrm>
-      </p:grpSpPr>
-      <p:sp>
-        <p:nvSpPr>
-          <p:cNvPr id="2" name="Text 0"/>
-          <p:cNvSpPr/>
-          <p:nvPr/>
-        </p:nvSpPr>
-        <p:spPr>
-          <a:xfrm>
-            <a:off x="457200" y="713232"/>
-            <a:ext cx="11368735" cy="274320"/>
-          </a:xfrm>
-          <a:prstGeom prst="rect">
-            <a:avLst/>
-          </a:prstGeom>
-          <a:noFill/>
-          <a:ln/>
-        </p:spPr>
-        <p:txBody>
-          <a:bodyPr wrap="square" lIns="0" tIns="0" rIns="0" bIns="0" rtlCol="0" anchor="ctr"/>
-          <a:lstStyle/>
-          <a:p>
-            <a:pPr algn="r" indent="0" marL="0">
-              <a:buNone/>
-            </a:pPr>
-            <a:r>
-              <a:rPr lang="en-US" sz="1400" b="1" dirty="0">
-                <a:solidFill>
-                  <a:srgbClr val="1C3F6E"/>
-                </a:solidFill>
-                <a:latin typeface="Calibri" pitchFamily="34" charset="0"/>
-                <a:ea typeface="Calibri" pitchFamily="34" charset="-122"/>
-                <a:cs typeface="Calibri" pitchFamily="34" charset="-120"/>
-              </a:rPr>
               <a:t>BILINGUAL GAME</a:t>
             </a:r>
             <a:endParaRPr lang="en-US" sz="1400" dirty="0"/>
@@ -22030,7 +20636,7 @@
       </p:sp>
       <p:graphicFrame>
         <p:nvGraphicFramePr>
-          <p:cNvPr id="62" name="Table 0"/>
+          <p:cNvPr id="59" name="Table 0"/>
           <p:cNvGraphicFramePr>
             <a:graphicFrameLocks noGrp="1"/>
           </p:cNvGraphicFramePr>
@@ -23066,7 +21672,7 @@
             <a:pPr algn="ctr"/>
             <a:fld id="{F7021451-1387-4CA6-816F-3879F97B5CBC}" type="slidenum">
               <a:rPr b="1" lang="en-US"/>
-              <a:t>61</a:t>
+              <a:t>58</a:t>
             </a:fld>
             <a:endParaRPr lang="en-US"/>
           </a:p>
@@ -23080,9 +21686,9 @@
 </p:sld>
 </file>
 
-<file path=ppt/slides/slide62.xml><?xml version="1.0" encoding="utf-8"?>
+<file path=ppt/slides/slide59.xml><?xml version="1.0" encoding="utf-8"?>
 <p:sld xmlns:a="http://schemas.openxmlformats.org/drawingml/2006/main" xmlns:r="http://schemas.openxmlformats.org/officeDocument/2006/relationships" xmlns:p="http://schemas.openxmlformats.org/presentationml/2006/main">
-  <p:cSld name="Slide 62">
+  <p:cSld name="Slide 59">
     <p:spTree>
       <p:nvGrpSpPr>
         <p:cNvPr id="1" name=""/>
@@ -23177,7 +21783,7 @@
       </p:sp>
       <p:graphicFrame>
         <p:nvGraphicFramePr>
-          <p:cNvPr id="63" name="Table 0"/>
+          <p:cNvPr id="60" name="Table 0"/>
           <p:cNvGraphicFramePr>
             <a:graphicFrameLocks noGrp="1"/>
           </p:cNvGraphicFramePr>
@@ -23799,7 +22405,7 @@
             <a:pPr algn="ctr"/>
             <a:fld id="{F7021451-1387-4CA6-816F-3879F97B5CBC}" type="slidenum">
               <a:rPr b="1" lang="en-US"/>
-              <a:t>62</a:t>
+              <a:t>59</a:t>
             </a:fld>
             <a:endParaRPr lang="en-US"/>
           </a:p>
@@ -23813,9 +22419,9 @@
 </p:sld>
 </file>
 
-<file path=ppt/slides/slide63.xml><?xml version="1.0" encoding="utf-8"?>
+<file path=ppt/slides/slide6.xml><?xml version="1.0" encoding="utf-8"?>
 <p:sld xmlns:a="http://schemas.openxmlformats.org/drawingml/2006/main" xmlns:r="http://schemas.openxmlformats.org/officeDocument/2006/relationships" xmlns:p="http://schemas.openxmlformats.org/presentationml/2006/main">
-  <p:cSld name="Slide 63">
+  <p:cSld name="Slide 6">
     <p:spTree>
       <p:nvGrpSpPr>
         <p:cNvPr id="1" name=""/>
@@ -23863,6 +22469,337 @@
                 <a:ea typeface="Calibri" pitchFamily="34" charset="-122"/>
                 <a:cs typeface="Calibri" pitchFamily="34" charset="-120"/>
               </a:rPr>
+              <a:t>LESSON PLAN</a:t>
+            </a:r>
+            <a:endParaRPr lang="en-US" sz="1400" dirty="0"/>
+          </a:p>
+        </p:txBody>
+      </p:sp>
+      <p:pic>
+        <p:nvPicPr>
+          <p:cNvPr id="3" name="Image 0" descr="/home/claude/f4/img/minesec_sheet.png">    </p:cNvPr>
+          <p:cNvPicPr>
+            <a:picLocks noChangeAspect="1"/>
+          </p:cNvPicPr>
+          <p:nvPr/>
+        </p:nvPicPr>
+        <p:blipFill>
+          <a:blip r:embed="rId1"/>
+          <a:stretch>
+            <a:fillRect/>
+          </a:stretch>
+        </p:blipFill>
+        <p:spPr>
+          <a:xfrm>
+            <a:off x="0" y="658368"/>
+            <a:ext cx="2468880" cy="5833872"/>
+          </a:xfrm>
+          <a:prstGeom prst="rect">
+            <a:avLst/>
+          </a:prstGeom>
+        </p:spPr>
+      </p:pic>
+      <p:sp>
+        <p:nvSpPr>
+          <p:cNvPr id="4" name="Text 1"/>
+          <p:cNvSpPr/>
+          <p:nvPr/>
+        </p:nvSpPr>
+        <p:spPr>
+          <a:xfrm>
+            <a:off x="2697480" y="1005840"/>
+            <a:ext cx="9174175" cy="731520"/>
+          </a:xfrm>
+          <a:prstGeom prst="rect">
+            <a:avLst/>
+          </a:prstGeom>
+          <a:noFill/>
+          <a:ln/>
+        </p:spPr>
+        <p:txBody>
+          <a:bodyPr wrap="square" lIns="0" tIns="0" rIns="0" bIns="0" rtlCol="0" anchor="ctr">
+            <a:normAutofit/>
+          </a:bodyPr>
+          <a:lstStyle/>
+          <a:p>
+            <a:pPr algn="ctr" indent="0" marL="0">
+              <a:buNone/>
+            </a:pPr>
+            <a:r>
+              <a:rPr lang="en-US" sz="3600" b="1" dirty="0">
+                <a:solidFill>
+                  <a:srgbClr val="990011"/>
+                </a:solidFill>
+                <a:latin typeface="Times New Roman" pitchFamily="34" charset="0"/>
+                <a:ea typeface="Times New Roman" pitchFamily="34" charset="-122"/>
+                <a:cs typeface="Times New Roman" pitchFamily="34" charset="-120"/>
+              </a:rPr>
+              <a:t>Lesson Plan</a:t>
+            </a:r>
+            <a:endParaRPr lang="en-US" sz="3600" dirty="0"/>
+          </a:p>
+        </p:txBody>
+      </p:sp>
+      <p:sp>
+        <p:nvSpPr>
+          <p:cNvPr id="5" name="Text 2"/>
+          <p:cNvSpPr/>
+          <p:nvPr/>
+        </p:nvSpPr>
+        <p:spPr>
+          <a:xfrm>
+            <a:off x="2697480" y="1783080"/>
+            <a:ext cx="9174175" cy="4663440"/>
+          </a:xfrm>
+          <a:prstGeom prst="rect">
+            <a:avLst/>
+          </a:prstGeom>
+          <a:noFill/>
+          <a:ln/>
+        </p:spPr>
+        <p:txBody>
+          <a:bodyPr wrap="square" lIns="0" tIns="0" rIns="0" bIns="0" rtlCol="0" anchor="t"/>
+          <a:lstStyle/>
+          <a:p>
+            <a:pPr algn="l" marL="342900" indent="-342900">
+              <a:spcAft>
+                <a:spcPts val="800"/>
+              </a:spcAft>
+              <a:buSzPct val="100000"/>
+              <a:buFont typeface="+mj-lt"/>
+              <a:buAutoNum type="arabicPeriod" startAt="1"/>
+            </a:pPr>
+            <a:r>
+              <a:rPr lang="en-US" sz="4000" dirty="0">
+                <a:solidFill>
+                  <a:srgbClr val="111111"/>
+                </a:solidFill>
+                <a:latin typeface="Times New Roman" pitchFamily="34" charset="0"/>
+                <a:ea typeface="Times New Roman" pitchFamily="34" charset="-122"/>
+                <a:cs typeface="Times New Roman" pitchFamily="34" charset="-120"/>
+              </a:rPr>
+              <a:t>Correction of the homework</a:t>
+            </a:r>
+            <a:endParaRPr lang="en-US" sz="4000" dirty="0"/>
+          </a:p>
+          <a:p>
+            <a:pPr algn="l" marL="342900" indent="-342900">
+              <a:spcAft>
+                <a:spcPts val="800"/>
+              </a:spcAft>
+              <a:buSzPct val="100000"/>
+              <a:buFont typeface="+mj-lt"/>
+              <a:buAutoNum type="arabicPeriod" startAt="1"/>
+            </a:pPr>
+            <a:r>
+              <a:rPr lang="en-US" sz="4000" dirty="0">
+                <a:solidFill>
+                  <a:srgbClr val="111111"/>
+                </a:solidFill>
+                <a:latin typeface="Times New Roman" pitchFamily="34" charset="0"/>
+                <a:ea typeface="Times New Roman" pitchFamily="34" charset="-122"/>
+                <a:cs typeface="Times New Roman" pitchFamily="34" charset="-120"/>
+              </a:rPr>
+              <a:t>Objectives and recall</a:t>
+            </a:r>
+            <a:endParaRPr lang="en-US" sz="4000" dirty="0"/>
+          </a:p>
+          <a:p>
+            <a:pPr algn="l" marL="342900" indent="-342900">
+              <a:spcAft>
+                <a:spcPts val="800"/>
+              </a:spcAft>
+              <a:buSzPct val="100000"/>
+              <a:buFont typeface="+mj-lt"/>
+              <a:buAutoNum type="arabicPeriod" startAt="1"/>
+            </a:pPr>
+            <a:r>
+              <a:rPr lang="en-US" sz="4000" dirty="0">
+                <a:solidFill>
+                  <a:srgbClr val="111111"/>
+                </a:solidFill>
+                <a:latin typeface="Times New Roman" pitchFamily="34" charset="0"/>
+                <a:ea typeface="Times New Roman" pitchFamily="34" charset="-122"/>
+                <a:cs typeface="Times New Roman" pitchFamily="34" charset="-120"/>
+              </a:rPr>
+              <a:t>Real-life situation and action to take</a:t>
+            </a:r>
+            <a:endParaRPr lang="en-US" sz="4000" dirty="0"/>
+          </a:p>
+          <a:p>
+            <a:pPr algn="l" marL="342900" indent="-342900">
+              <a:spcAft>
+                <a:spcPts val="800"/>
+              </a:spcAft>
+              <a:buSzPct val="100000"/>
+              <a:buFont typeface="+mj-lt"/>
+              <a:buAutoNum type="arabicPeriod" startAt="1"/>
+            </a:pPr>
+            <a:r>
+              <a:rPr lang="en-US" sz="4000" dirty="0">
+                <a:solidFill>
+                  <a:srgbClr val="111111"/>
+                </a:solidFill>
+                <a:latin typeface="Times New Roman" pitchFamily="34" charset="0"/>
+                <a:ea typeface="Times New Roman" pitchFamily="34" charset="-122"/>
+                <a:cs typeface="Times New Roman" pitchFamily="34" charset="-120"/>
+              </a:rPr>
+              <a:t>Learning activities</a:t>
+            </a:r>
+            <a:endParaRPr lang="en-US" sz="4000" dirty="0"/>
+          </a:p>
+          <a:p>
+            <a:pPr algn="l" marL="342900" indent="-342900">
+              <a:spcAft>
+                <a:spcPts val="800"/>
+              </a:spcAft>
+              <a:buSzPct val="100000"/>
+              <a:buFont typeface="+mj-lt"/>
+              <a:buAutoNum type="arabicPeriod" startAt="1"/>
+            </a:pPr>
+            <a:r>
+              <a:rPr lang="en-US" sz="4000" dirty="0">
+                <a:solidFill>
+                  <a:srgbClr val="111111"/>
+                </a:solidFill>
+                <a:latin typeface="Times New Roman" pitchFamily="34" charset="0"/>
+                <a:ea typeface="Times New Roman" pitchFamily="34" charset="-122"/>
+                <a:cs typeface="Times New Roman" pitchFamily="34" charset="-120"/>
+              </a:rPr>
+              <a:t>Board summary</a:t>
+            </a:r>
+            <a:endParaRPr lang="en-US" sz="4000" dirty="0"/>
+          </a:p>
+          <a:p>
+            <a:pPr algn="l" marL="342900" indent="-342900">
+              <a:spcAft>
+                <a:spcPts val="800"/>
+              </a:spcAft>
+              <a:buSzPct val="100000"/>
+              <a:buFont typeface="+mj-lt"/>
+              <a:buAutoNum type="arabicPeriod" startAt="1"/>
+            </a:pPr>
+            <a:r>
+              <a:rPr lang="en-US" sz="4000" dirty="0">
+                <a:solidFill>
+                  <a:srgbClr val="111111"/>
+                </a:solidFill>
+                <a:latin typeface="Times New Roman" pitchFamily="34" charset="0"/>
+                <a:ea typeface="Times New Roman" pitchFamily="34" charset="-122"/>
+                <a:cs typeface="Times New Roman" pitchFamily="34" charset="-120"/>
+              </a:rPr>
+              <a:t>Evaluation, remediation and homework</a:t>
+            </a:r>
+            <a:endParaRPr lang="en-US" sz="4000" dirty="0"/>
+          </a:p>
+        </p:txBody>
+      </p:sp>
+      <p:sp>
+        <p:nvSpPr>
+          <p:cNvPr id="25" name="Slide Number Placeholder 0"/>
+          <p:cNvSpPr>
+            <a:spLocks noGrp="1"/>
+          </p:cNvSpPr>
+          <p:nvPr>
+            <p:ph type="sldNum" sz="quarter" idx="4294967295"/>
+          </p:nvPr>
+        </p:nvSpPr>
+        <p:spPr>
+          <a:xfrm>
+            <a:off x="27432" y="91440"/>
+            <a:ext cx="585216" cy="475488"/>
+          </a:xfrm>
+          <a:prstGeom prst="rect">
+            <a:avLst/>
+          </a:prstGeom>
+          <a:extLst>
+            <a:ext uri="{C572A759-6A51-4108-AA02-DFA0A04FC94B}">
+              <ma14:wrappingTextBoxFlag xmlns:ma14="http://schemas.microsoft.com/office/mac/drawingml/2011/main" val="0"/>
+            </a:ext>
+          </a:extLst>
+        </p:spPr>
+        <p:txBody>
+          <a:bodyPr/>
+          <a:lstStyle>
+            <a:lvl1pPr>
+              <a:defRPr sz="2000">
+                <a:solidFill>
+                  <a:srgbClr val="FFFFFF"/>
+                </a:solidFill>
+                <a:latin typeface="Calibri"/>
+                <a:ea typeface="Calibri"/>
+                <a:cs typeface="Calibri"/>
+              </a:defRPr>
+            </a:lvl1pPr>
+          </a:lstStyle>
+          <a:p>
+            <a:pPr algn="ctr"/>
+            <a:fld id="{F7021451-1387-4CA6-816F-3879F97B5CBC}" type="slidenum">
+              <a:rPr b="1" lang="en-US"/>
+              <a:t>6</a:t>
+            </a:fld>
+            <a:endParaRPr lang="en-US"/>
+          </a:p>
+        </p:txBody>
+      </p:sp>
+    </p:spTree>
+  </p:cSld>
+  <p:clrMapOvr>
+    <a:masterClrMapping/>
+  </p:clrMapOvr>
+</p:sld>
+</file>
+
+<file path=ppt/slides/slide60.xml><?xml version="1.0" encoding="utf-8"?>
+<p:sld xmlns:a="http://schemas.openxmlformats.org/drawingml/2006/main" xmlns:r="http://schemas.openxmlformats.org/officeDocument/2006/relationships" xmlns:p="http://schemas.openxmlformats.org/presentationml/2006/main">
+  <p:cSld name="Slide 60">
+    <p:spTree>
+      <p:nvGrpSpPr>
+        <p:cNvPr id="1" name=""/>
+        <p:cNvGrpSpPr/>
+        <p:nvPr/>
+      </p:nvGrpSpPr>
+      <p:grpSpPr>
+        <a:xfrm>
+          <a:off x="0" y="0"/>
+          <a:ext cx="0" cy="0"/>
+          <a:chOff x="0" y="0"/>
+          <a:chExt cx="0" cy="0"/>
+        </a:xfrm>
+      </p:grpSpPr>
+      <p:sp>
+        <p:nvSpPr>
+          <p:cNvPr id="2" name="Text 0"/>
+          <p:cNvSpPr/>
+          <p:nvPr/>
+        </p:nvSpPr>
+        <p:spPr>
+          <a:xfrm>
+            <a:off x="457200" y="713232"/>
+            <a:ext cx="11368735" cy="274320"/>
+          </a:xfrm>
+          <a:prstGeom prst="rect">
+            <a:avLst/>
+          </a:prstGeom>
+          <a:noFill/>
+          <a:ln/>
+        </p:spPr>
+        <p:txBody>
+          <a:bodyPr wrap="square" lIns="0" tIns="0" rIns="0" bIns="0" rtlCol="0" anchor="ctr"/>
+          <a:lstStyle/>
+          <a:p>
+            <a:pPr algn="r" indent="0" marL="0">
+              <a:buNone/>
+            </a:pPr>
+            <a:r>
+              <a:rPr lang="en-US" sz="1400" b="1" dirty="0">
+                <a:solidFill>
+                  <a:srgbClr val="1C3F6E"/>
+                </a:solidFill>
+                <a:latin typeface="Calibri" pitchFamily="34" charset="0"/>
+                <a:ea typeface="Calibri" pitchFamily="34" charset="-122"/>
+                <a:cs typeface="Calibri" pitchFamily="34" charset="-120"/>
+              </a:rPr>
               <a:t>LOGBOOK</a:t>
             </a:r>
             <a:endParaRPr lang="en-US" sz="1400" dirty="0"/>
@@ -23910,7 +22847,7 @@
       </p:sp>
       <p:graphicFrame>
         <p:nvGraphicFramePr>
-          <p:cNvPr id="64" name="Table 0"/>
+          <p:cNvPr id="61" name="Table 0"/>
           <p:cNvGraphicFramePr>
             <a:graphicFrameLocks noGrp="1"/>
           </p:cNvGraphicFramePr>
@@ -24020,7 +22957,7 @@
                           <a:ea typeface="Calibri" pitchFamily="34" charset="-122"/>
                           <a:cs typeface="Calibri" pitchFamily="34" charset="-120"/>
                         </a:rPr>
-                        <a:t>DEFINITIONS; Techniques of Mapping Population Distribution and Density; Other Methods Showing Unevenness; Assessment of the Techniques.</a:t>
+                        <a:t>DEFINITIONS; Techniques of Mapping Population Distribution and Density; Showing Uneven Distribution; Assessment of the Techniques.</a:t>
                       </a:r>
                       <a:endParaRPr lang="en-US" sz="1600" dirty="0">
                         <a:latin typeface="Calibri" charset="0"/>
@@ -24670,7 +23607,7 @@
             <a:pPr algn="ctr"/>
             <a:fld id="{F7021451-1387-4CA6-816F-3879F97B5CBC}" type="slidenum">
               <a:rPr b="1" lang="en-US"/>
-              <a:t>63</a:t>
+              <a:t>60</a:t>
             </a:fld>
             <a:endParaRPr lang="en-US"/>
           </a:p>
@@ -24684,9 +23621,9 @@
 </p:sld>
 </file>
 
-<file path=ppt/slides/slide64.xml><?xml version="1.0" encoding="utf-8"?>
+<file path=ppt/slides/slide61.xml><?xml version="1.0" encoding="utf-8"?>
 <p:sld xmlns:a="http://schemas.openxmlformats.org/drawingml/2006/main" xmlns:r="http://schemas.openxmlformats.org/officeDocument/2006/relationships" xmlns:p="http://schemas.openxmlformats.org/presentationml/2006/main">
-  <p:cSld name="Slide 64">
+  <p:cSld name="Slide 61">
     <p:spTree>
       <p:nvGrpSpPr>
         <p:cNvPr id="1" name=""/>
@@ -24995,7 +23932,7 @@
             <a:pPr algn="ctr"/>
             <a:fld id="{F7021451-1387-4CA6-816F-3879F97B5CBC}" type="slidenum">
               <a:rPr b="1" lang="en-US"/>
-              <a:t>64</a:t>
+              <a:t>61</a:t>
             </a:fld>
             <a:endParaRPr lang="en-US"/>
           </a:p>
@@ -25009,9 +23946,9 @@
 </p:sld>
 </file>
 
-<file path=ppt/slides/slide65.xml><?xml version="1.0" encoding="utf-8"?>
+<file path=ppt/slides/slide62.xml><?xml version="1.0" encoding="utf-8"?>
 <p:sld xmlns:a="http://schemas.openxmlformats.org/drawingml/2006/main" xmlns:r="http://schemas.openxmlformats.org/officeDocument/2006/relationships" xmlns:p="http://schemas.openxmlformats.org/presentationml/2006/main">
-  <p:cSld name="Slide 65">
+  <p:cSld name="Slide 62">
     <p:spTree>
       <p:nvGrpSpPr>
         <p:cNvPr id="1" name=""/>
@@ -25278,7 +24215,7 @@
             <a:pPr algn="ctr"/>
             <a:fld id="{F7021451-1387-4CA6-816F-3879F97B5CBC}" type="slidenum">
               <a:rPr b="1" lang="en-US"/>
-              <a:t>65</a:t>
+              <a:t>62</a:t>
             </a:fld>
             <a:endParaRPr lang="en-US"/>
           </a:p>

</xml_diff>